<commit_message>
new k anonymity for all qi
</commit_message>
<xml_diff>
--- a/paper_and_presentation/PPIA_HW1_presentation_v1.pptx
+++ b/paper_and_presentation/PPIA_HW1_presentation_v1.pptx
@@ -4,6 +4,9 @@
   <p:sldMasterIdLst>
     <p:sldMasterId id="2147483648" r:id="rId1"/>
   </p:sldMasterIdLst>
+  <p:notesMasterIdLst>
+    <p:notesMasterId r:id="rId12"/>
+  </p:notesMasterIdLst>
   <p:sldIdLst>
     <p:sldId id="256" r:id="rId2"/>
     <p:sldId id="257" r:id="rId3"/>
@@ -16,10 +19,7 @@
     <p:sldId id="264" r:id="rId10"/>
     <p:sldId id="265" r:id="rId11"/>
   </p:sldIdLst>
-  <p:notesMasterIdLst>
-    <p:notesMasterId r:id="rId12"/>
-  </p:notesMasterIdLst>
-  <p:sldSz cx="9144000" cy="5143500"/>
+  <p:sldSz cx="9144000" cy="5143500" type="screen16x9"/>
   <p:notesSz cx="5143500" cy="9144000"/>
   <p:defaultTextStyle>
     <a:lvl1pPr marL="0" algn="l" defTabSz="914400" rtl="0" eaLnBrk="1" latinLnBrk="0" hangingPunct="1">
@@ -116,12 +116,12 @@
   <p:extLst>
     <p:ext uri="{521415D9-36F7-43E2-AB2F-B90AF26B5E84}">
       <p14:sectionLst xmlns:p14="http://schemas.microsoft.com/office/powerpoint/2010/main">
-        <p14:section name="Introduction" id="{789fb0bd-c871-be31-22eb-449b94f185d0}">
+        <p14:section name="Introduction" id="{789FB0BD-C871-BE31-22EB-449B94F185D0}">
           <p14:sldIdLst>
             <p14:sldId id="256"/>
           </p14:sldIdLst>
         </p14:section>
-        <p14:section name="Setting and data" id="{ecf01c55-4729-b3c3-2639-0e774a62f21f}">
+        <p14:section name="Setting and data" id="{ECF01C55-4729-B3C3-2639-0E774A62F21F}">
           <p14:sldIdLst>
             <p14:sldId id="257"/>
             <p14:sldId id="258"/>
@@ -129,19 +129,19 @@
             <p14:sldId id="260"/>
           </p14:sldIdLst>
         </p14:section>
-        <p14:section name="Utility" id="{fc524c00-70eb-347f-f8d0-f0dbec2bb9cf}">
+        <p14:section name="Utility" id="{FC524C00-70EB-347F-F8D0-F0DBEC2BB9CF}">
           <p14:sldIdLst>
             <p14:sldId id="261"/>
           </p14:sldIdLst>
         </p14:section>
-        <p14:section name="Anonymization" id="{f3bd4c8f-626f-fee8-fb2b-00f75bcc4470}">
+        <p14:section name="Anonymization" id="{F3BD4C8F-626F-FEE8-FB2B-00F75BCC4470}">
           <p14:sldIdLst>
             <p14:sldId id="262"/>
             <p14:sldId id="263"/>
             <p14:sldId id="264"/>
           </p14:sldIdLst>
         </p14:section>
-        <p14:section name="Conclusions" id="{2916f717-81b8-8fb0-b2e4-bda49e02ca6e}">
+        <p14:section name="Conclusions" id="{2916F717-81B8-8FB0-B2E4-BDA49E02CA6E}">
           <p14:sldIdLst>
             <p14:sldId id="265"/>
           </p14:sldIdLst>
@@ -177,234 +177,10 @@
           <a:chExt cx="0" cy="0"/>
         </a:xfrm>
       </p:grpSpPr>
-      <p:sp>
-        <p:nvSpPr>
-          <p:cNvPr id="2" name="Header Placeholder 1"/>
-          <p:cNvSpPr>
-            <a:spLocks noGrp="1"/>
-          </p:cNvSpPr>
-          <p:nvPr>
-            <p:ph type="hdr" sz="quarter"/>
-          </p:nvPr>
-        </p:nvSpPr>
-        <p:spPr>
-          <a:xfrm>
-            <a:off x="0" y="0"/>
-            <a:ext cx="2971800" cy="458788"/>
-          </a:xfrm>
-          <a:prstGeom prst="rect">
-            <a:avLst/>
-          </a:prstGeom>
-        </p:spPr>
-        <p:txBody>
-          <a:bodyPr vert="horz" lIns="91440" tIns="45720" rIns="91440" bIns="45720" rtlCol="0"/>
-          <a:lstStyle>
-            <a:lvl1pPr algn="l">
-              <a:defRPr sz="1200"/>
-            </a:lvl1pPr>
-          </a:lstStyle>
-          <a:p>
-            <a:endParaRPr lang="en-US"/>
-          </a:p>
-        </p:txBody>
-      </p:sp>
-      <p:sp>
-        <p:nvSpPr>
-          <p:cNvPr id="3" name="Date Placeholder 2"/>
-          <p:cNvSpPr>
-            <a:spLocks noGrp="1"/>
-          </p:cNvSpPr>
-          <p:nvPr>
-            <p:ph type="dt" idx="1"/>
-          </p:nvPr>
-        </p:nvSpPr>
-        <p:spPr>
-          <a:xfrm>
-            <a:off x="3884613" y="0"/>
-            <a:ext cx="2971800" cy="458788"/>
-          </a:xfrm>
-          <a:prstGeom prst="rect">
-            <a:avLst/>
-          </a:prstGeom>
-        </p:spPr>
-        <p:txBody>
-          <a:bodyPr vert="horz" lIns="91440" tIns="45720" rIns="91440" bIns="45720" rtlCol="0"/>
-          <a:lstStyle>
-            <a:lvl1pPr algn="r">
-              <a:defRPr sz="1200"/>
-            </a:lvl1pPr>
-          </a:lstStyle>
-          <a:p>
-            <a:fld id="{5282F153-3F37-0F45-9E97-73ACFA13230C}" type="datetimeFigureOut">
-              <a:rPr lang="en-US"/>
-              <a:t>7/23/19</a:t>
-            </a:fld>
-            <a:endParaRPr lang="en-US"/>
-          </a:p>
-        </p:txBody>
-      </p:sp>
-      <p:sp>
-        <p:nvSpPr>
-          <p:cNvPr id="4" name="Slide Image Placeholder 3"/>
-          <p:cNvSpPr>
-            <a:spLocks noGrp="1" noRot="1" noChangeAspect="1"/>
-          </p:cNvSpPr>
-          <p:nvPr>
-            <p:ph type="sldImg" idx="2"/>
-          </p:nvPr>
-        </p:nvSpPr>
-        <p:spPr>
-          <a:xfrm>
-            <a:off x="685800" y="1143000"/>
-            <a:ext cx="5486400" cy="3086100"/>
-          </a:xfrm>
-          <a:prstGeom prst="rect">
-            <a:avLst/>
-          </a:prstGeom>
-          <a:noFill/>
-          <a:ln w="12700">
-            <a:solidFill>
-              <a:prstClr val="black"/>
-            </a:solidFill>
-          </a:ln>
-        </p:spPr>
-        <p:txBody>
-          <a:bodyPr vert="horz" lIns="91440" tIns="45720" rIns="91440" bIns="45720" rtlCol="0" anchor="ctr"/>
-          <a:lstStyle/>
-          <a:p>
-            <a:endParaRPr lang="en-US"/>
-          </a:p>
-        </p:txBody>
-      </p:sp>
-      <p:sp>
-        <p:nvSpPr>
-          <p:cNvPr id="5" name="Notes Placeholder 4"/>
-          <p:cNvSpPr>
-            <a:spLocks noGrp="1"/>
-          </p:cNvSpPr>
-          <p:nvPr>
-            <p:ph type="body" sz="quarter" idx="3"/>
-          </p:nvPr>
-        </p:nvSpPr>
-        <p:spPr>
-          <a:xfrm>
-            <a:off x="685800" y="4400550"/>
-            <a:ext cx="5486400" cy="3600450"/>
-          </a:xfrm>
-          <a:prstGeom prst="rect">
-            <a:avLst/>
-          </a:prstGeom>
-        </p:spPr>
-        <p:txBody>
-          <a:bodyPr vert="horz" lIns="91440" tIns="45720" rIns="91440" bIns="45720" rtlCol="0"/>
-          <a:lstStyle/>
-          <a:p>
-            <a:pPr lvl="0"/>
-            <a:r>
-              <a:rPr lang="en-US"/>
-              <a:t>Click to edit Master text styles</a:t>
-            </a:r>
-          </a:p>
-          <a:p>
-            <a:pPr lvl="1"/>
-            <a:r>
-              <a:rPr lang="en-US"/>
-              <a:t>Second level</a:t>
-            </a:r>
-          </a:p>
-          <a:p>
-            <a:pPr lvl="2"/>
-            <a:r>
-              <a:rPr lang="en-US"/>
-              <a:t>Third level</a:t>
-            </a:r>
-          </a:p>
-          <a:p>
-            <a:pPr lvl="3"/>
-            <a:r>
-              <a:rPr lang="en-US"/>
-              <a:t>Fourth level</a:t>
-            </a:r>
-          </a:p>
-          <a:p>
-            <a:pPr lvl="4"/>
-            <a:r>
-              <a:rPr lang="en-US"/>
-              <a:t>Fifth level</a:t>
-            </a:r>
-          </a:p>
-        </p:txBody>
-      </p:sp>
-      <p:sp>
-        <p:nvSpPr>
-          <p:cNvPr id="6" name="Footer Placeholder 5"/>
-          <p:cNvSpPr>
-            <a:spLocks noGrp="1"/>
-          </p:cNvSpPr>
-          <p:nvPr>
-            <p:ph type="ftr" sz="quarter" idx="4"/>
-          </p:nvPr>
-        </p:nvSpPr>
-        <p:spPr>
-          <a:xfrm>
-            <a:off x="0" y="8685213"/>
-            <a:ext cx="2971800" cy="458787"/>
-          </a:xfrm>
-          <a:prstGeom prst="rect">
-            <a:avLst/>
-          </a:prstGeom>
-        </p:spPr>
-        <p:txBody>
-          <a:bodyPr vert="horz" lIns="91440" tIns="45720" rIns="91440" bIns="45720" rtlCol="0" anchor="b"/>
-          <a:lstStyle>
-            <a:lvl1pPr algn="l">
-              <a:defRPr sz="1200"/>
-            </a:lvl1pPr>
-          </a:lstStyle>
-          <a:p>
-            <a:endParaRPr lang="en-US"/>
-          </a:p>
-        </p:txBody>
-      </p:sp>
-      <p:sp>
-        <p:nvSpPr>
-          <p:cNvPr id="7" name="Slide Number Placeholder 6"/>
-          <p:cNvSpPr>
-            <a:spLocks noGrp="1"/>
-          </p:cNvSpPr>
-          <p:nvPr>
-            <p:ph type="sldNum" sz="quarter" idx="5"/>
-          </p:nvPr>
-        </p:nvSpPr>
-        <p:spPr>
-          <a:xfrm>
-            <a:off x="3884613" y="8685213"/>
-            <a:ext cx="2971800" cy="458787"/>
-          </a:xfrm>
-          <a:prstGeom prst="rect">
-            <a:avLst/>
-          </a:prstGeom>
-        </p:spPr>
-        <p:txBody>
-          <a:bodyPr vert="horz" lIns="91440" tIns="45720" rIns="91440" bIns="45720" rtlCol="0" anchor="b"/>
-          <a:lstStyle>
-            <a:lvl1pPr algn="r">
-              <a:defRPr sz="1200"/>
-            </a:lvl1pPr>
-          </a:lstStyle>
-          <a:p>
-            <a:fld id="{CE5E9CC1-C706-0F49-92D6-E571CC5EEA8F}" type="slidenum">
-              <a:rPr lang="en-US"/>
-              <a:t>‹#›</a:t>
-            </a:fld>
-            <a:endParaRPr lang="en-US"/>
-          </a:p>
-        </p:txBody>
-      </p:sp>
     </p:spTree>
     <p:extLst>
       <p:ext uri="{BB962C8B-B14F-4D97-AF65-F5344CB8AC3E}">
-        <p14:creationId xmlns:p14="http://schemas.microsoft.com/office/powerpoint/2010/main" val="1024086991"/>
+        <p14:creationId xmlns:p14="http://schemas.microsoft.com/office/powerpoint/2010/main" val="2353447717"/>
       </p:ext>
     </p:extLst>
   </p:cSld>
@@ -552,7 +328,6 @@
               <a:rPr lang="en-US" dirty="0"/>
               <a:t>(~15 s) Hi, we are group 5: Ivan, Laszlo and Maxime. Our homework is about anonymizing the Google Local Reviews dataset, so that it can be published for research without exposing the people who wrote the reviews.</a:t>
             </a:r>
-            <a:endParaRPr lang="en-US" dirty="0"/>
           </a:p>
         </p:txBody>
       </p:sp>
@@ -640,7 +415,6 @@
               <a:rPr lang="en-US" dirty="0"/>
               <a:t>(~40 s) To conclude: we kept every review, removed the direct link to the reviewer, and the analyses we care about still work. Next steps would be l-diversity and t-closeness. Three questions for you. First: k = 5 holds for the place alone, but on month, category, rating and spent together only 48% of reviews are in a group of at least five. Should k-anonymity cover all quasi-identifiers together? Second: a group made only of health or religious places still leaks that fact. Is l-diversity a must? Third: could an LLM sentiment score replace the length class safely? Thank you!</a:t>
             </a:r>
-            <a:endParaRPr lang="en-US" dirty="0"/>
           </a:p>
         </p:txBody>
       </p:sp>
@@ -728,7 +502,6 @@
               <a:rPr lang="en-US" dirty="0"/>
               <a:t>(~35 s) We used the Google Local Reviews dataset from the McAuley Lab at UC San Diego: public Google Maps reviews up to 2021, one file per US state. We took Vermont: after removing about ten thousand duplicates, almost 842 thousand reviews from 288 thousand users about 11 thousand places. We also generated one synthetic attribute, the amount spent, so we have a financial value to protect. This kind of data is used for recommender systems and customer-satisfaction research, but every row is a real person at a real place. Our goal is to release it while the reviewers stay private.</a:t>
             </a:r>
-            <a:endParaRPr lang="en-US" dirty="0"/>
           </a:p>
         </p:txBody>
       </p:sp>
@@ -816,7 +589,6 @@
               <a:rPr lang="en-US" dirty="0"/>
               <a:t>(~40 s) This table is the core of our analysis. The identifiers are the name, usually the real one, and the user_id, which leads to the public Google profile and joins all reviews of one person; both are removed. The quasi-identifiers don't identify anyone alone but do in combination: the time, the place, the rating and the amount spent. The sensitive attributes are the free text and the owner's reply, which can contain names, family or health details, the photos, and again the spending. The last column already shows what we publish for each one; we'll come back to it in the code.</a:t>
             </a:r>
-            <a:endParaRPr lang="en-US" dirty="0"/>
           </a:p>
         </p:txBody>
       </p:sp>
@@ -904,7 +676,6 @@
               <a:rPr lang="en-US" dirty="0"/>
               <a:t>(~30 s) Why is this dangerous in Vermont? Almost two thirds of users wrote just one review, and more than a third of the places have fewer than ten. So the crowd to hide in is tiny. The timestamps are unique, and some places are sensitive in themselves, like clinics or churches. Knowing the place and roughly when someone was there is often enough to find their review.</a:t>
             </a:r>
-            <a:endParaRPr lang="en-US" dirty="0"/>
           </a:p>
         </p:txBody>
       </p:sp>
@@ -992,7 +763,6 @@
               <a:rPr lang="en-US" dirty="0"/>
               <a:t>(~35 s) Once the data is public, anyone can download it: data brokers and profilers, advertisers, insurers or employers, or simply someone who knows the victim. The attack is record linkage. The user_id leads to the public profile and to reviews in other states. Name, town and month can be matched with social networks or public registers. Addresses of hotels or home services can be joined with property records. And the attacker only gets stronger over time, while a released copy can never be taken back.</a:t>
             </a:r>
-            <a:endParaRPr lang="en-US" dirty="0"/>
           </a:p>
         </p:txBody>
       </p:sp>
@@ -1080,7 +850,6 @@
               <a:rPr lang="en-US" dirty="0"/>
               <a:t>(~35 s) As our utility measure we asked: is the length of a review related to its rating? On the original data, clearly yes: short reviews are only about 5% negative, while reviews over 1,000 characters are almost 50% negative. After anonymization we only publish three length classes, and the pattern is still there: 5, 11 and 35% negative. So the main finding survives.</a:t>
             </a:r>
-            <a:endParaRPr lang="en-US" dirty="0"/>
           </a:p>
         </p:txBody>
       </p:sp>
@@ -1168,7 +937,6 @@
               <a:rPr lang="en-US" dirty="0"/>
               <a:t>(~35 s) Now the code. First, user_id and name are removed. For the date we drop the time of day and keep only the year and month, one step up the generalization hierarchy: 3,939 distinct days become 177 months. The review text and the owner's reply are replaced by a length class: short under 50 characters, medium up to 500, long above. For replies we also keep the delay between the review and the reply.</a:t>
             </a:r>
-            <a:endParaRPr lang="en-US" dirty="0"/>
           </a:p>
         </p:txBody>
       </p:sp>
@@ -1256,7 +1024,6 @@
               <a:rPr lang="en-US" dirty="0"/>
               <a:t>(~35 s) The amount spent starts out very spread out, from free parks to car purchases over ten thousand dollars, as the figure shows. Inside each type of place we raise everything below the 5% quantile and cap everything above the 95% quantile, because one huge purchase identifies a review on its own. Then we round to a ladder of tiers and merge tiers with less than 5% of the reviews. Only seven values remain, from 0 to 500 dollars, at the price of a median relative error of about 19%.</a:t>
             </a:r>
-            <a:endParaRPr lang="en-US" dirty="0"/>
           </a:p>
         </p:txBody>
       </p:sp>
@@ -1344,7 +1111,6 @@
               <a:rPr lang="en-US" dirty="0"/>
               <a:t>(~35 s) The most dangerous quasi-identifier left was the place, since many places have very few reviews. We replace the place ID with its categories, and every group we publish must have at least five reviews. The code is a three-step ladder: keep the full category list if five reviews share it, otherwise only the first category, and as a last resort we suppress the place for that review. 99.85% of reviews keep the full list, 1,031 lose the place, and nothing is deleted.</a:t>
             </a:r>
-            <a:endParaRPr lang="en-US" dirty="0"/>
           </a:p>
         </p:txBody>
       </p:sp>
@@ -1422,6 +1188,7 @@
         <a:solidFill>
           <a:srgbClr val="FFFFFF"/>
         </a:solidFill>
+        <a:effectLst/>
       </p:bgPr>
     </p:bg>
     <p:spTree>
@@ -1441,9 +1208,11 @@
       <p:sp>
         <p:nvSpPr>
           <p:cNvPr id="2" name="Text 0"/>
-          <p:cNvSpPr/>
+          <p:cNvSpPr>
+            <a:spLocks noGrp="1"/>
+          </p:cNvSpPr>
           <p:nvPr>
-            <p:ph idx="100" type="title" hasCustomPrompt="1"/>
+            <p:ph type="title" idx="100" hasCustomPrompt="1"/>
           </p:nvPr>
         </p:nvSpPr>
         <p:spPr>
@@ -1460,7 +1229,7 @@
         <p:txBody>
           <a:bodyPr wrap="square" rtlCol="0"/>
           <a:lstStyle>
-            <a:lvl1pPr algn="l" indent="0" marL="0">
+            <a:lvl1pPr marL="0" indent="0" algn="l">
               <a:buNone/>
               <a:defRPr lang="en-US" sz="2600" dirty="0">
                 <a:solidFill>
@@ -1470,7 +1239,7 @@
             </a:lvl1pPr>
           </a:lstStyle>
           <a:p>
-            <a:pPr algn="l" indent="0" marL="0">
+            <a:pPr marL="0" indent="0" algn="l">
               <a:buNone/>
             </a:pPr>
             <a:endParaRPr lang="en-US" sz="2600" dirty="0"/>
@@ -1498,7 +1267,7 @@
           <a:bodyPr wrap="square" lIns="0" tIns="0" rIns="0" bIns="0" rtlCol="0" anchor="ctr"/>
           <a:lstStyle/>
           <a:p>
-            <a:pPr indent="0" marL="0">
+            <a:pPr marL="0" indent="0">
               <a:buNone/>
             </a:pPr>
             <a:r>
@@ -1533,7 +1302,7 @@
           </a:prstGeom>
           <a:extLst>
             <a:ext uri="{C572A759-6A51-4108-AA02-DFA0A04FC94B}">
-              <ma14:wrappingTextBoxFlag xmlns:ma14="http://schemas.microsoft.com/office/mac/drawingml/2011/main" val="0"/>
+              <ma14:wrappingTextBoxFlag xmlns:ma14="http://schemas.microsoft.com/office/mac/drawingml/2011/main" xmlns="" val="0"/>
             </a:ext>
           </a:extLst>
         </p:spPr>
@@ -1551,8 +1320,8 @@
           <a:p>
             <a:pPr algn="r"/>
             <a:fld id="{F7021451-1387-4CA6-816F-3879F97B5CBC}" type="slidenum">
-              <a:rPr b="0" lang="en-US"/>
-              <a:t>1002</a:t>
+              <a:rPr lang="en-US" b="0"/>
+              <a:t>‹#›</a:t>
             </a:fld>
             <a:endParaRPr lang="en-US"/>
           </a:p>
@@ -1574,6 +1343,7 @@
         <a:solidFill>
           <a:srgbClr val="FFFFFF"/>
         </a:solidFill>
+        <a:effectLst/>
       </p:bgPr>
     </p:bg>
     <p:spTree>
@@ -1601,6 +1371,11 @@
 <file path=ppt/slideMasters/slideMaster1.xml><?xml version="1.0" encoding="utf-8"?>
 <p:sldMaster xmlns:a="http://schemas.openxmlformats.org/drawingml/2006/main" xmlns:r="http://schemas.openxmlformats.org/officeDocument/2006/relationships" xmlns:p="http://schemas.openxmlformats.org/presentationml/2006/main">
   <p:cSld>
+    <p:bg>
+      <p:bgRef idx="1001">
+        <a:schemeClr val="bg1"/>
+      </p:bgRef>
+    </p:bg>
     <p:spTree>
       <p:nvGrpSpPr>
         <p:cNvPr id="1" name=""/>
@@ -1635,7 +1410,7 @@
           </a:prstGeom>
           <a:extLst>
             <a:ext uri="{C572A759-6A51-4108-AA02-DFA0A04FC94B}">
-              <ma14:wrappingTextBoxFlag xmlns:ma14="http://schemas.microsoft.com/office/mac/drawingml/2011/main" val="0"/>
+              <ma14:wrappingTextBoxFlag xmlns:ma14="http://schemas.microsoft.com/office/mac/drawingml/2011/main" xmlns="" val="0"/>
             </a:ext>
           </a:extLst>
         </p:spPr>
@@ -1653,8 +1428,8 @@
           <a:p>
             <a:pPr algn="r"/>
             <a:fld id="{F7021451-1387-4CA6-816F-3879F97B5CBC}" type="slidenum">
-              <a:rPr b="0" lang="en-US"/>
-              <a:t>null</a:t>
+              <a:rPr lang="en-US" b="0"/>
+              <a:t>‹#›</a:t>
             </a:fld>
             <a:endParaRPr lang="en-US"/>
           </a:p>
@@ -1960,7 +1735,7 @@
           <a:bodyPr wrap="square" lIns="0" tIns="0" rIns="0" bIns="0" rtlCol="0" anchor="t"/>
           <a:lstStyle/>
           <a:p>
-            <a:pPr indent="0" marL="0">
+            <a:pPr marL="0" indent="0">
               <a:buNone/>
             </a:pPr>
             <a:r>
@@ -1996,7 +1771,7 @@
           <a:bodyPr wrap="square" lIns="0" tIns="0" rIns="0" bIns="0" rtlCol="0" anchor="t"/>
           <a:lstStyle/>
           <a:p>
-            <a:pPr indent="0" marL="0">
+            <a:pPr marL="0" indent="0">
               <a:buNone/>
             </a:pPr>
             <a:r>
@@ -2013,7 +1788,7 @@
             <a:endParaRPr lang="en-US" sz="3600" dirty="0"/>
           </a:p>
           <a:p>
-            <a:pPr indent="0" marL="0">
+            <a:pPr marL="0" indent="0">
               <a:buNone/>
             </a:pPr>
             <a:r>
@@ -2052,7 +1827,7 @@
           <a:bodyPr wrap="square" lIns="0" tIns="0" rIns="0" bIns="0" rtlCol="0" anchor="t"/>
           <a:lstStyle/>
           <a:p>
-            <a:pPr indent="0" marL="0">
+            <a:pPr marL="0" indent="0">
               <a:buNone/>
             </a:pPr>
             <a:r>
@@ -2088,7 +1863,7 @@
           <a:bodyPr wrap="square" lIns="0" tIns="0" rIns="0" bIns="0" rtlCol="0" anchor="t"/>
           <a:lstStyle/>
           <a:p>
-            <a:pPr indent="0" marL="0">
+            <a:pPr marL="0" indent="0">
               <a:buNone/>
             </a:pPr>
             <a:r>
@@ -2131,9 +1906,11 @@
       <p:sp>
         <p:nvSpPr>
           <p:cNvPr id="2" name="Text 0"/>
-          <p:cNvSpPr/>
+          <p:cNvSpPr>
+            <a:spLocks noGrp="1"/>
+          </p:cNvSpPr>
           <p:nvPr>
-            <p:ph idx="100" type="title" hasCustomPrompt="1"/>
+            <p:ph type="title" idx="100" hasCustomPrompt="1"/>
           </p:nvPr>
         </p:nvSpPr>
         <p:spPr>
@@ -2151,7 +1928,7 @@
           <a:bodyPr wrap="square" lIns="0" tIns="0" rIns="0" bIns="0" rtlCol="0" anchor="ctr"/>
           <a:lstStyle/>
           <a:p>
-            <a:pPr algn="l" indent="0" marL="0">
+            <a:pPr marL="0" indent="0" algn="l">
               <a:buNone/>
             </a:pPr>
             <a:r>
@@ -2187,7 +1964,7 @@
           <a:bodyPr wrap="square" lIns="0" tIns="0" rIns="0" bIns="0" rtlCol="0" anchor="t"/>
           <a:lstStyle/>
           <a:p>
-            <a:pPr indent="0" marL="0">
+            <a:pPr marL="0" indent="0">
               <a:buNone/>
             </a:pPr>
             <a:r>
@@ -2299,7 +2076,7 @@
           <a:bodyPr wrap="square" lIns="0" tIns="0" rIns="0" bIns="0" rtlCol="0" anchor="t"/>
           <a:lstStyle/>
           <a:p>
-            <a:pPr indent="0" marL="0">
+            <a:pPr marL="0" indent="0">
               <a:buNone/>
             </a:pPr>
             <a:r>
@@ -2341,7 +2118,7 @@
               </a:spcAft>
               <a:buSzPct val="100000"/>
               <a:buFont typeface="+mj-lt"/>
-              <a:buAutoNum type="arabicPeriod" startAt="1"/>
+              <a:buAutoNum type="arabicPeriod"/>
             </a:pPr>
             <a:r>
               <a:rPr lang="en-US" sz="1400" dirty="0">
@@ -2349,7 +2126,7 @@
                   <a:schemeClr val="tx1"/>
                 </a:solidFill>
               </a:rPr>
-              <a:t>On month + category + rating + spent together, only 48% of reviews are in a group of ≥ 5. Should k-anonymity cover all quasi-identifiers at once?</a:t>
+              <a:t>Something about k-anonymity </a:t>
             </a:r>
             <a:endParaRPr lang="en-US" sz="1400" dirty="0"/>
           </a:p>
@@ -2360,7 +2137,7 @@
               </a:spcAft>
               <a:buSzPct val="100000"/>
               <a:buFont typeface="+mj-lt"/>
-              <a:buAutoNum type="arabicPeriod" startAt="1"/>
+              <a:buAutoNum type="arabicPeriod"/>
             </a:pPr>
             <a:r>
               <a:rPr lang="en-US" sz="1400" dirty="0">
@@ -2379,7 +2156,7 @@
               </a:spcAft>
               <a:buSzPct val="100000"/>
               <a:buFont typeface="+mj-lt"/>
-              <a:buAutoNum type="arabicPeriod" startAt="1"/>
+              <a:buAutoNum type="arabicPeriod"/>
             </a:pPr>
             <a:r>
               <a:rPr lang="en-US" sz="1400" dirty="0">
@@ -2414,7 +2191,7 @@
           <a:bodyPr wrap="square" lIns="0" tIns="0" rIns="0" bIns="0" rtlCol="0" anchor="t"/>
           <a:lstStyle/>
           <a:p>
-            <a:pPr indent="0" marL="0">
+            <a:pPr marL="0" indent="0">
               <a:buNone/>
             </a:pPr>
             <a:r>
@@ -2452,7 +2229,7 @@
           </a:prstGeom>
           <a:extLst>
             <a:ext uri="{C572A759-6A51-4108-AA02-DFA0A04FC94B}">
-              <ma14:wrappingTextBoxFlag xmlns:ma14="http://schemas.microsoft.com/office/mac/drawingml/2011/main" val="0"/>
+              <ma14:wrappingTextBoxFlag xmlns:ma14="http://schemas.microsoft.com/office/mac/drawingml/2011/main" xmlns="" val="0"/>
             </a:ext>
           </a:extLst>
         </p:spPr>
@@ -2470,7 +2247,7 @@
           <a:p>
             <a:pPr algn="r"/>
             <a:fld id="{F7021451-1387-4CA6-816F-3879F97B5CBC}" type="slidenum">
-              <a:rPr b="0" lang="en-US"/>
+              <a:rPr lang="en-US" b="0"/>
               <a:t>10</a:t>
             </a:fld>
             <a:endParaRPr lang="en-US"/>
@@ -2505,9 +2282,11 @@
       <p:sp>
         <p:nvSpPr>
           <p:cNvPr id="2" name="Text 0"/>
-          <p:cNvSpPr/>
+          <p:cNvSpPr>
+            <a:spLocks noGrp="1"/>
+          </p:cNvSpPr>
           <p:nvPr>
-            <p:ph idx="100" type="title" hasCustomPrompt="1"/>
+            <p:ph type="title" idx="100" hasCustomPrompt="1"/>
           </p:nvPr>
         </p:nvSpPr>
         <p:spPr>
@@ -2525,7 +2304,7 @@
           <a:bodyPr wrap="square" lIns="0" tIns="0" rIns="0" bIns="0" rtlCol="0" anchor="ctr"/>
           <a:lstStyle/>
           <a:p>
-            <a:pPr algn="l" indent="0" marL="0">
+            <a:pPr marL="0" indent="0" algn="l">
               <a:buNone/>
             </a:pPr>
             <a:r>
@@ -2582,7 +2361,7 @@
                   <a:schemeClr val="tx1"/>
                 </a:solidFill>
               </a:rPr>
-              <a:t> (McAuley Lab, UC San Diego): public Google Maps reviews up to Sept 2021</a:t>
+              <a:t> public Google Maps reviews up to Sept 2021</a:t>
             </a:r>
             <a:endParaRPr lang="en-US" sz="1500" dirty="0"/>
           </a:p>
@@ -2679,7 +2458,7 @@
           <a:bodyPr wrap="square" lIns="0" tIns="0" rIns="0" bIns="0" rtlCol="0" anchor="t"/>
           <a:lstStyle/>
           <a:p>
-            <a:pPr indent="0" marL="0">
+            <a:pPr marL="0" indent="0">
               <a:buNone/>
             </a:pPr>
             <a:r>
@@ -2715,7 +2494,7 @@
           <a:bodyPr wrap="square" lIns="0" tIns="0" rIns="0" bIns="0" rtlCol="0" anchor="t"/>
           <a:lstStyle/>
           <a:p>
-            <a:pPr indent="0" marL="0">
+            <a:pPr marL="0" indent="0">
               <a:buNone/>
             </a:pPr>
             <a:r>
@@ -2732,7 +2511,7 @@
       </p:sp>
       <p:graphicFrame>
         <p:nvGraphicFramePr>
-          <p:cNvPr id="3" name="dataset table"/>
+          <p:cNvPr id="6" name="dataset table"/>
           <p:cNvGraphicFramePr>
             <a:graphicFrameLocks noGrp="1"/>
           </p:cNvGraphicFramePr>
@@ -2746,15 +2525,27 @@
         </p:nvGraphicFramePr>
         <p:xfrm>
           <a:off x="5303520" y="1463040"/>
-          <a:ext cx="3291840" cy="914400"/>
+          <a:ext cx="3291840" cy="2084832"/>
         </p:xfrm>
         <a:graphic>
           <a:graphicData uri="http://schemas.openxmlformats.org/drawingml/2006/table">
             <a:tbl>
               <a:tblPr/>
               <a:tblGrid>
-                <a:gridCol w="1828800"/>
-                <a:gridCol w="1463040"/>
+                <a:gridCol w="1828800">
+                  <a:extLst>
+                    <a:ext uri="{9D8B030D-6E8A-4147-A177-3AD203B41FA5}">
+                      <a16:colId xmlns:a16="http://schemas.microsoft.com/office/drawing/2014/main" val="20000"/>
+                    </a:ext>
+                  </a:extLst>
+                </a:gridCol>
+                <a:gridCol w="1463040">
+                  <a:extLst>
+                    <a:ext uri="{9D8B030D-6E8A-4147-A177-3AD203B41FA5}">
+                      <a16:colId xmlns:a16="http://schemas.microsoft.com/office/drawing/2014/main" val="20001"/>
+                    </a:ext>
+                  </a:extLst>
+                </a:gridCol>
               </a:tblGrid>
               <a:tr h="347472">
                 <a:tc>
@@ -2762,7 +2553,7 @@
                     <a:bodyPr/>
                     <a:lstStyle/>
                     <a:p>
-                      <a:pPr algn="l" indent="0" marL="0">
+                      <a:pPr marL="0" indent="0" algn="l">
                         <a:buNone/>
                       </a:pPr>
                       <a:endParaRPr lang="en-US" sz="1300" dirty="0">
@@ -2804,7 +2595,7 @@
                     <a:bodyPr/>
                     <a:lstStyle/>
                     <a:p>
-                      <a:pPr algn="r" indent="0" marL="0">
+                      <a:pPr marL="0" indent="0" algn="r">
                         <a:buNone/>
                       </a:pPr>
                       <a:r>
@@ -2852,6 +2643,11 @@
                     </a:lnB>
                   </a:tcPr>
                 </a:tc>
+                <a:extLst>
+                  <a:ext uri="{0D108BD9-81ED-4DB2-BD59-A6C34878D82A}">
+                    <a16:rowId xmlns:a16="http://schemas.microsoft.com/office/drawing/2014/main" val="10000"/>
+                  </a:ext>
+                </a:extLst>
               </a:tr>
               <a:tr h="347472">
                 <a:tc>
@@ -2859,7 +2655,7 @@
                     <a:bodyPr/>
                     <a:lstStyle/>
                     <a:p>
-                      <a:pPr algn="l" indent="0" marL="0">
+                      <a:pPr marL="0" indent="0" algn="l">
                         <a:buNone/>
                       </a:pPr>
                       <a:r>
@@ -2887,8 +2683,14 @@
                     <a:lnR w="0" cap="flat" cmpd="sng" algn="ctr">
                       <a:noFill/>
                     </a:lnR>
-                    <a:lnT w="0" cap="flat" cmpd="sng" algn="ctr">
-                      <a:noFill/>
+                    <a:lnT w="9525" cap="flat" cmpd="sng" algn="ctr">
+                      <a:solidFill>
+                        <a:srgbClr val="222222"/>
+                      </a:solidFill>
+                      <a:prstDash val="solid"/>
+                      <a:round/>
+                      <a:headEnd type="none" w="med" len="med"/>
+                      <a:tailEnd type="none" w="med" len="med"/>
                     </a:lnT>
                     <a:lnB w="6350" cap="flat" cmpd="sng" algn="ctr">
                       <a:solidFill>
@@ -2906,7 +2708,7 @@
                     <a:bodyPr/>
                     <a:lstStyle/>
                     <a:p>
-                      <a:pPr algn="r" indent="0" marL="0">
+                      <a:pPr marL="0" indent="0" algn="r">
                         <a:buNone/>
                       </a:pPr>
                       <a:r>
@@ -2934,8 +2736,14 @@
                     <a:lnR w="0" cap="flat" cmpd="sng" algn="ctr">
                       <a:noFill/>
                     </a:lnR>
-                    <a:lnT w="0" cap="flat" cmpd="sng" algn="ctr">
-                      <a:noFill/>
+                    <a:lnT w="9525" cap="flat" cmpd="sng" algn="ctr">
+                      <a:solidFill>
+                        <a:srgbClr val="222222"/>
+                      </a:solidFill>
+                      <a:prstDash val="solid"/>
+                      <a:round/>
+                      <a:headEnd type="none" w="med" len="med"/>
+                      <a:tailEnd type="none" w="med" len="med"/>
                     </a:lnT>
                     <a:lnB w="6350" cap="flat" cmpd="sng" algn="ctr">
                       <a:solidFill>
@@ -2948,6 +2756,11 @@
                     </a:lnB>
                   </a:tcPr>
                 </a:tc>
+                <a:extLst>
+                  <a:ext uri="{0D108BD9-81ED-4DB2-BD59-A6C34878D82A}">
+                    <a16:rowId xmlns:a16="http://schemas.microsoft.com/office/drawing/2014/main" val="10001"/>
+                  </a:ext>
+                </a:extLst>
               </a:tr>
               <a:tr h="347472">
                 <a:tc>
@@ -2955,7 +2768,7 @@
                     <a:bodyPr/>
                     <a:lstStyle/>
                     <a:p>
-                      <a:pPr algn="l" indent="0" marL="0">
+                      <a:pPr marL="0" indent="0" algn="l">
                         <a:buNone/>
                       </a:pPr>
                       <a:r>
@@ -2983,8 +2796,14 @@
                     <a:lnR w="0" cap="flat" cmpd="sng" algn="ctr">
                       <a:noFill/>
                     </a:lnR>
-                    <a:lnT w="0" cap="flat" cmpd="sng" algn="ctr">
-                      <a:noFill/>
+                    <a:lnT w="6350" cap="flat" cmpd="sng" algn="ctr">
+                      <a:solidFill>
+                        <a:srgbClr val="E3E3E3"/>
+                      </a:solidFill>
+                      <a:prstDash val="solid"/>
+                      <a:round/>
+                      <a:headEnd type="none" w="med" len="med"/>
+                      <a:tailEnd type="none" w="med" len="med"/>
                     </a:lnT>
                     <a:lnB w="6350" cap="flat" cmpd="sng" algn="ctr">
                       <a:solidFill>
@@ -3002,7 +2821,7 @@
                     <a:bodyPr/>
                     <a:lstStyle/>
                     <a:p>
-                      <a:pPr algn="r" indent="0" marL="0">
+                      <a:pPr marL="0" indent="0" algn="r">
                         <a:buNone/>
                       </a:pPr>
                       <a:r>
@@ -3030,8 +2849,14 @@
                     <a:lnR w="0" cap="flat" cmpd="sng" algn="ctr">
                       <a:noFill/>
                     </a:lnR>
-                    <a:lnT w="0" cap="flat" cmpd="sng" algn="ctr">
-                      <a:noFill/>
+                    <a:lnT w="6350" cap="flat" cmpd="sng" algn="ctr">
+                      <a:solidFill>
+                        <a:srgbClr val="E3E3E3"/>
+                      </a:solidFill>
+                      <a:prstDash val="solid"/>
+                      <a:round/>
+                      <a:headEnd type="none" w="med" len="med"/>
+                      <a:tailEnd type="none" w="med" len="med"/>
                     </a:lnT>
                     <a:lnB w="6350" cap="flat" cmpd="sng" algn="ctr">
                       <a:solidFill>
@@ -3044,6 +2869,11 @@
                     </a:lnB>
                   </a:tcPr>
                 </a:tc>
+                <a:extLst>
+                  <a:ext uri="{0D108BD9-81ED-4DB2-BD59-A6C34878D82A}">
+                    <a16:rowId xmlns:a16="http://schemas.microsoft.com/office/drawing/2014/main" val="10002"/>
+                  </a:ext>
+                </a:extLst>
               </a:tr>
               <a:tr h="347472">
                 <a:tc>
@@ -3051,7 +2881,7 @@
                     <a:bodyPr/>
                     <a:lstStyle/>
                     <a:p>
-                      <a:pPr algn="l" indent="0" marL="0">
+                      <a:pPr marL="0" indent="0" algn="l">
                         <a:buNone/>
                       </a:pPr>
                       <a:r>
@@ -3079,8 +2909,14 @@
                     <a:lnR w="0" cap="flat" cmpd="sng" algn="ctr">
                       <a:noFill/>
                     </a:lnR>
-                    <a:lnT w="0" cap="flat" cmpd="sng" algn="ctr">
-                      <a:noFill/>
+                    <a:lnT w="6350" cap="flat" cmpd="sng" algn="ctr">
+                      <a:solidFill>
+                        <a:srgbClr val="E3E3E3"/>
+                      </a:solidFill>
+                      <a:prstDash val="solid"/>
+                      <a:round/>
+                      <a:headEnd type="none" w="med" len="med"/>
+                      <a:tailEnd type="none" w="med" len="med"/>
                     </a:lnT>
                     <a:lnB w="6350" cap="flat" cmpd="sng" algn="ctr">
                       <a:solidFill>
@@ -3098,7 +2934,7 @@
                     <a:bodyPr/>
                     <a:lstStyle/>
                     <a:p>
-                      <a:pPr algn="r" indent="0" marL="0">
+                      <a:pPr marL="0" indent="0" algn="r">
                         <a:buNone/>
                       </a:pPr>
                       <a:r>
@@ -3126,8 +2962,14 @@
                     <a:lnR w="0" cap="flat" cmpd="sng" algn="ctr">
                       <a:noFill/>
                     </a:lnR>
-                    <a:lnT w="0" cap="flat" cmpd="sng" algn="ctr">
-                      <a:noFill/>
+                    <a:lnT w="6350" cap="flat" cmpd="sng" algn="ctr">
+                      <a:solidFill>
+                        <a:srgbClr val="E3E3E3"/>
+                      </a:solidFill>
+                      <a:prstDash val="solid"/>
+                      <a:round/>
+                      <a:headEnd type="none" w="med" len="med"/>
+                      <a:tailEnd type="none" w="med" len="med"/>
                     </a:lnT>
                     <a:lnB w="6350" cap="flat" cmpd="sng" algn="ctr">
                       <a:solidFill>
@@ -3140,6 +2982,11 @@
                     </a:lnB>
                   </a:tcPr>
                 </a:tc>
+                <a:extLst>
+                  <a:ext uri="{0D108BD9-81ED-4DB2-BD59-A6C34878D82A}">
+                    <a16:rowId xmlns:a16="http://schemas.microsoft.com/office/drawing/2014/main" val="10003"/>
+                  </a:ext>
+                </a:extLst>
               </a:tr>
               <a:tr h="347472">
                 <a:tc>
@@ -3147,7 +2994,7 @@
                     <a:bodyPr/>
                     <a:lstStyle/>
                     <a:p>
-                      <a:pPr algn="l" indent="0" marL="0">
+                      <a:pPr marL="0" indent="0" algn="l">
                         <a:buNone/>
                       </a:pPr>
                       <a:r>
@@ -3175,8 +3022,14 @@
                     <a:lnR w="0" cap="flat" cmpd="sng" algn="ctr">
                       <a:noFill/>
                     </a:lnR>
-                    <a:lnT w="0" cap="flat" cmpd="sng" algn="ctr">
-                      <a:noFill/>
+                    <a:lnT w="6350" cap="flat" cmpd="sng" algn="ctr">
+                      <a:solidFill>
+                        <a:srgbClr val="E3E3E3"/>
+                      </a:solidFill>
+                      <a:prstDash val="solid"/>
+                      <a:round/>
+                      <a:headEnd type="none" w="med" len="med"/>
+                      <a:tailEnd type="none" w="med" len="med"/>
                     </a:lnT>
                     <a:lnB w="6350" cap="flat" cmpd="sng" algn="ctr">
                       <a:solidFill>
@@ -3194,7 +3047,7 @@
                     <a:bodyPr/>
                     <a:lstStyle/>
                     <a:p>
-                      <a:pPr algn="r" indent="0" marL="0">
+                      <a:pPr marL="0" indent="0" algn="r">
                         <a:buNone/>
                       </a:pPr>
                       <a:r>
@@ -3222,8 +3075,14 @@
                     <a:lnR w="0" cap="flat" cmpd="sng" algn="ctr">
                       <a:noFill/>
                     </a:lnR>
-                    <a:lnT w="0" cap="flat" cmpd="sng" algn="ctr">
-                      <a:noFill/>
+                    <a:lnT w="6350" cap="flat" cmpd="sng" algn="ctr">
+                      <a:solidFill>
+                        <a:srgbClr val="E3E3E3"/>
+                      </a:solidFill>
+                      <a:prstDash val="solid"/>
+                      <a:round/>
+                      <a:headEnd type="none" w="med" len="med"/>
+                      <a:tailEnd type="none" w="med" len="med"/>
                     </a:lnT>
                     <a:lnB w="6350" cap="flat" cmpd="sng" algn="ctr">
                       <a:solidFill>
@@ -3236,6 +3095,11 @@
                     </a:lnB>
                   </a:tcPr>
                 </a:tc>
+                <a:extLst>
+                  <a:ext uri="{0D108BD9-81ED-4DB2-BD59-A6C34878D82A}">
+                    <a16:rowId xmlns:a16="http://schemas.microsoft.com/office/drawing/2014/main" val="10004"/>
+                  </a:ext>
+                </a:extLst>
               </a:tr>
               <a:tr h="347472">
                 <a:tc>
@@ -3243,7 +3107,7 @@
                     <a:bodyPr/>
                     <a:lstStyle/>
                     <a:p>
-                      <a:pPr algn="l" indent="0" marL="0">
+                      <a:pPr marL="0" indent="0" algn="l">
                         <a:buNone/>
                       </a:pPr>
                       <a:r>
@@ -3271,8 +3135,14 @@
                     <a:lnR w="0" cap="flat" cmpd="sng" algn="ctr">
                       <a:noFill/>
                     </a:lnR>
-                    <a:lnT w="0" cap="flat" cmpd="sng" algn="ctr">
-                      <a:noFill/>
+                    <a:lnT w="6350" cap="flat" cmpd="sng" algn="ctr">
+                      <a:solidFill>
+                        <a:srgbClr val="E3E3E3"/>
+                      </a:solidFill>
+                      <a:prstDash val="solid"/>
+                      <a:round/>
+                      <a:headEnd type="none" w="med" len="med"/>
+                      <a:tailEnd type="none" w="med" len="med"/>
                     </a:lnT>
                     <a:lnB w="15875" cap="flat" cmpd="sng" algn="ctr">
                       <a:solidFill>
@@ -3290,7 +3160,7 @@
                     <a:bodyPr/>
                     <a:lstStyle/>
                     <a:p>
-                      <a:pPr algn="r" indent="0" marL="0">
+                      <a:pPr marL="0" indent="0" algn="r">
                         <a:buNone/>
                       </a:pPr>
                       <a:r>
@@ -3318,8 +3188,14 @@
                     <a:lnR w="0" cap="flat" cmpd="sng" algn="ctr">
                       <a:noFill/>
                     </a:lnR>
-                    <a:lnT w="0" cap="flat" cmpd="sng" algn="ctr">
-                      <a:noFill/>
+                    <a:lnT w="6350" cap="flat" cmpd="sng" algn="ctr">
+                      <a:solidFill>
+                        <a:srgbClr val="E3E3E3"/>
+                      </a:solidFill>
+                      <a:prstDash val="solid"/>
+                      <a:round/>
+                      <a:headEnd type="none" w="med" len="med"/>
+                      <a:tailEnd type="none" w="med" len="med"/>
                     </a:lnT>
                     <a:lnB w="15875" cap="flat" cmpd="sng" algn="ctr">
                       <a:solidFill>
@@ -3332,6 +3208,11 @@
                     </a:lnB>
                   </a:tcPr>
                 </a:tc>
+                <a:extLst>
+                  <a:ext uri="{0D108BD9-81ED-4DB2-BD59-A6C34878D82A}">
+                    <a16:rowId xmlns:a16="http://schemas.microsoft.com/office/drawing/2014/main" val="10005"/>
+                  </a:ext>
+                </a:extLst>
               </a:tr>
             </a:tbl>
           </a:graphicData>
@@ -3357,7 +3238,7 @@
           </a:prstGeom>
           <a:extLst>
             <a:ext uri="{C572A759-6A51-4108-AA02-DFA0A04FC94B}">
-              <ma14:wrappingTextBoxFlag xmlns:ma14="http://schemas.microsoft.com/office/mac/drawingml/2011/main" val="0"/>
+              <ma14:wrappingTextBoxFlag xmlns:ma14="http://schemas.microsoft.com/office/mac/drawingml/2011/main" xmlns="" val="0"/>
             </a:ext>
           </a:extLst>
         </p:spPr>
@@ -3375,7 +3256,7 @@
           <a:p>
             <a:pPr algn="r"/>
             <a:fld id="{F7021451-1387-4CA6-816F-3879F97B5CBC}" type="slidenum">
-              <a:rPr b="0" lang="en-US"/>
+              <a:rPr lang="en-US" b="0"/>
               <a:t>2</a:t>
             </a:fld>
             <a:endParaRPr lang="en-US"/>
@@ -3410,9 +3291,11 @@
       <p:sp>
         <p:nvSpPr>
           <p:cNvPr id="2" name="Text 0"/>
-          <p:cNvSpPr/>
+          <p:cNvSpPr>
+            <a:spLocks noGrp="1"/>
+          </p:cNvSpPr>
           <p:nvPr>
-            <p:ph idx="100" type="title" hasCustomPrompt="1"/>
+            <p:ph type="title" idx="100" hasCustomPrompt="1"/>
           </p:nvPr>
         </p:nvSpPr>
         <p:spPr>
@@ -3430,7 +3313,7 @@
           <a:bodyPr wrap="square" lIns="0" tIns="0" rIns="0" bIns="0" rtlCol="0" anchor="ctr"/>
           <a:lstStyle/>
           <a:p>
-            <a:pPr algn="l" indent="0" marL="0">
+            <a:pPr marL="0" indent="0" algn="l">
               <a:buNone/>
             </a:pPr>
             <a:r>
@@ -3454,23 +3337,41 @@
           <p:nvPr>
             <p:extLst>
               <p:ext uri="{D42A27DB-BD31-4B8C-83A1-F6EECF244321}">
-                <p14:modId xmlns:p14="http://schemas.microsoft.com/office/powerpoint/2010/main" val="1579011935"/>
+                <p14:modId xmlns:p14="http://schemas.microsoft.com/office/powerpoint/2010/main" val="933306285"/>
               </p:ext>
             </p:extLst>
           </p:nvPr>
         </p:nvGraphicFramePr>
         <p:xfrm>
           <a:off x="548640" y="1143000"/>
-          <a:ext cx="8046720" cy="914400"/>
+          <a:ext cx="8046720" cy="3209544"/>
         </p:xfrm>
         <a:graphic>
           <a:graphicData uri="http://schemas.openxmlformats.org/drawingml/2006/table">
             <a:tbl>
               <a:tblPr/>
               <a:tblGrid>
-                <a:gridCol w="2377440"/>
-                <a:gridCol w="2651760"/>
-                <a:gridCol w="3017520"/>
+                <a:gridCol w="2377440">
+                  <a:extLst>
+                    <a:ext uri="{9D8B030D-6E8A-4147-A177-3AD203B41FA5}">
+                      <a16:colId xmlns:a16="http://schemas.microsoft.com/office/drawing/2014/main" val="20000"/>
+                    </a:ext>
+                  </a:extLst>
+                </a:gridCol>
+                <a:gridCol w="2651760">
+                  <a:extLst>
+                    <a:ext uri="{9D8B030D-6E8A-4147-A177-3AD203B41FA5}">
+                      <a16:colId xmlns:a16="http://schemas.microsoft.com/office/drawing/2014/main" val="20001"/>
+                    </a:ext>
+                  </a:extLst>
+                </a:gridCol>
+                <a:gridCol w="3017520">
+                  <a:extLst>
+                    <a:ext uri="{9D8B030D-6E8A-4147-A177-3AD203B41FA5}">
+                      <a16:colId xmlns:a16="http://schemas.microsoft.com/office/drawing/2014/main" val="20002"/>
+                    </a:ext>
+                  </a:extLst>
+                </a:gridCol>
               </a:tblGrid>
               <a:tr h="356616">
                 <a:tc>
@@ -3478,7 +3379,7 @@
                     <a:bodyPr/>
                     <a:lstStyle/>
                     <a:p>
-                      <a:pPr algn="l" indent="0" marL="0">
+                      <a:pPr marL="0" indent="0" algn="l">
                         <a:buNone/>
                       </a:pPr>
                       <a:r>
@@ -3531,7 +3432,7 @@
                     <a:bodyPr/>
                     <a:lstStyle/>
                     <a:p>
-                      <a:pPr algn="l" indent="0" marL="0">
+                      <a:pPr marL="0" indent="0" algn="l">
                         <a:buNone/>
                       </a:pPr>
                       <a:r>
@@ -3584,7 +3485,7 @@
                     <a:bodyPr/>
                     <a:lstStyle/>
                     <a:p>
-                      <a:pPr algn="l" indent="0" marL="0">
+                      <a:pPr marL="0" indent="0" algn="l">
                         <a:buNone/>
                       </a:pPr>
                       <a:r>
@@ -3632,6 +3533,11 @@
                     </a:lnB>
                   </a:tcPr>
                 </a:tc>
+                <a:extLst>
+                  <a:ext uri="{0D108BD9-81ED-4DB2-BD59-A6C34878D82A}">
+                    <a16:rowId xmlns:a16="http://schemas.microsoft.com/office/drawing/2014/main" val="10000"/>
+                  </a:ext>
+                </a:extLst>
               </a:tr>
               <a:tr h="356616">
                 <a:tc>
@@ -3639,7 +3545,7 @@
                     <a:bodyPr/>
                     <a:lstStyle/>
                     <a:p>
-                      <a:pPr algn="l" indent="0" marL="0">
+                      <a:pPr marL="0" indent="0" algn="l">
                         <a:buNone/>
                       </a:pPr>
                       <a:r>
@@ -3667,8 +3573,14 @@
                     <a:lnR w="0" cap="flat" cmpd="sng" algn="ctr">
                       <a:noFill/>
                     </a:lnR>
-                    <a:lnT w="0" cap="flat" cmpd="sng" algn="ctr">
-                      <a:noFill/>
+                    <a:lnT w="9525" cap="flat" cmpd="sng" algn="ctr">
+                      <a:solidFill>
+                        <a:srgbClr val="222222"/>
+                      </a:solidFill>
+                      <a:prstDash val="solid"/>
+                      <a:round/>
+                      <a:headEnd type="none" w="med" len="med"/>
+                      <a:tailEnd type="none" w="med" len="med"/>
                     </a:lnT>
                     <a:lnB w="6350" cap="flat" cmpd="sng" algn="ctr">
                       <a:solidFill>
@@ -3686,7 +3598,7 @@
                     <a:bodyPr/>
                     <a:lstStyle/>
                     <a:p>
-                      <a:pPr algn="l" indent="0" marL="0">
+                      <a:pPr marL="0" indent="0" algn="l">
                         <a:buNone/>
                       </a:pPr>
                       <a:r>
@@ -3714,8 +3626,14 @@
                     <a:lnR w="0" cap="flat" cmpd="sng" algn="ctr">
                       <a:noFill/>
                     </a:lnR>
-                    <a:lnT w="0" cap="flat" cmpd="sng" algn="ctr">
-                      <a:noFill/>
+                    <a:lnT w="9525" cap="flat" cmpd="sng" algn="ctr">
+                      <a:solidFill>
+                        <a:srgbClr val="222222"/>
+                      </a:solidFill>
+                      <a:prstDash val="solid"/>
+                      <a:round/>
+                      <a:headEnd type="none" w="med" len="med"/>
+                      <a:tailEnd type="none" w="med" len="med"/>
                     </a:lnT>
                     <a:lnB w="6350" cap="flat" cmpd="sng" algn="ctr">
                       <a:solidFill>
@@ -3733,7 +3651,7 @@
                     <a:bodyPr/>
                     <a:lstStyle/>
                     <a:p>
-                      <a:pPr algn="l" indent="0" marL="0">
+                      <a:pPr marL="0" indent="0" algn="l">
                         <a:buNone/>
                       </a:pPr>
                       <a:r>
@@ -3761,8 +3679,14 @@
                     <a:lnR w="0" cap="flat" cmpd="sng" algn="ctr">
                       <a:noFill/>
                     </a:lnR>
-                    <a:lnT w="0" cap="flat" cmpd="sng" algn="ctr">
-                      <a:noFill/>
+                    <a:lnT w="9525" cap="flat" cmpd="sng" algn="ctr">
+                      <a:solidFill>
+                        <a:srgbClr val="222222"/>
+                      </a:solidFill>
+                      <a:prstDash val="solid"/>
+                      <a:round/>
+                      <a:headEnd type="none" w="med" len="med"/>
+                      <a:tailEnd type="none" w="med" len="med"/>
                     </a:lnT>
                     <a:lnB w="6350" cap="flat" cmpd="sng" algn="ctr">
                       <a:solidFill>
@@ -3775,6 +3699,11 @@
                     </a:lnB>
                   </a:tcPr>
                 </a:tc>
+                <a:extLst>
+                  <a:ext uri="{0D108BD9-81ED-4DB2-BD59-A6C34878D82A}">
+                    <a16:rowId xmlns:a16="http://schemas.microsoft.com/office/drawing/2014/main" val="10001"/>
+                  </a:ext>
+                </a:extLst>
               </a:tr>
               <a:tr h="356616">
                 <a:tc>
@@ -3782,7 +3711,7 @@
                     <a:bodyPr/>
                     <a:lstStyle/>
                     <a:p>
-                      <a:pPr algn="l" indent="0" marL="0">
+                      <a:pPr marL="0" indent="0" algn="l">
                         <a:buNone/>
                       </a:pPr>
                       <a:r>
@@ -3810,8 +3739,14 @@
                     <a:lnR w="0" cap="flat" cmpd="sng" algn="ctr">
                       <a:noFill/>
                     </a:lnR>
-                    <a:lnT w="0" cap="flat" cmpd="sng" algn="ctr">
-                      <a:noFill/>
+                    <a:lnT w="6350" cap="flat" cmpd="sng" algn="ctr">
+                      <a:solidFill>
+                        <a:srgbClr val="E3E3E3"/>
+                      </a:solidFill>
+                      <a:prstDash val="solid"/>
+                      <a:round/>
+                      <a:headEnd type="none" w="med" len="med"/>
+                      <a:tailEnd type="none" w="med" len="med"/>
                     </a:lnT>
                     <a:lnB w="6350" cap="flat" cmpd="sng" algn="ctr">
                       <a:solidFill>
@@ -3829,7 +3764,7 @@
                     <a:bodyPr/>
                     <a:lstStyle/>
                     <a:p>
-                      <a:pPr algn="l" indent="0" marL="0">
+                      <a:pPr marL="0" indent="0" algn="l">
                         <a:buNone/>
                       </a:pPr>
                       <a:r>
@@ -3857,8 +3792,14 @@
                     <a:lnR w="0" cap="flat" cmpd="sng" algn="ctr">
                       <a:noFill/>
                     </a:lnR>
-                    <a:lnT w="0" cap="flat" cmpd="sng" algn="ctr">
-                      <a:noFill/>
+                    <a:lnT w="6350" cap="flat" cmpd="sng" algn="ctr">
+                      <a:solidFill>
+                        <a:srgbClr val="E3E3E3"/>
+                      </a:solidFill>
+                      <a:prstDash val="solid"/>
+                      <a:round/>
+                      <a:headEnd type="none" w="med" len="med"/>
+                      <a:tailEnd type="none" w="med" len="med"/>
                     </a:lnT>
                     <a:lnB w="6350" cap="flat" cmpd="sng" algn="ctr">
                       <a:solidFill>
@@ -3876,7 +3817,7 @@
                     <a:bodyPr/>
                     <a:lstStyle/>
                     <a:p>
-                      <a:pPr algn="l" indent="0" marL="0">
+                      <a:pPr marL="0" indent="0" algn="l">
                         <a:buNone/>
                       </a:pPr>
                       <a:r>
@@ -3904,8 +3845,14 @@
                     <a:lnR w="0" cap="flat" cmpd="sng" algn="ctr">
                       <a:noFill/>
                     </a:lnR>
-                    <a:lnT w="0" cap="flat" cmpd="sng" algn="ctr">
-                      <a:noFill/>
+                    <a:lnT w="6350" cap="flat" cmpd="sng" algn="ctr">
+                      <a:solidFill>
+                        <a:srgbClr val="E3E3E3"/>
+                      </a:solidFill>
+                      <a:prstDash val="solid"/>
+                      <a:round/>
+                      <a:headEnd type="none" w="med" len="med"/>
+                      <a:tailEnd type="none" w="med" len="med"/>
                     </a:lnT>
                     <a:lnB w="6350" cap="flat" cmpd="sng" algn="ctr">
                       <a:solidFill>
@@ -3918,6 +3865,11 @@
                     </a:lnB>
                   </a:tcPr>
                 </a:tc>
+                <a:extLst>
+                  <a:ext uri="{0D108BD9-81ED-4DB2-BD59-A6C34878D82A}">
+                    <a16:rowId xmlns:a16="http://schemas.microsoft.com/office/drawing/2014/main" val="10002"/>
+                  </a:ext>
+                </a:extLst>
               </a:tr>
               <a:tr h="356616">
                 <a:tc>
@@ -3925,7 +3877,7 @@
                     <a:bodyPr/>
                     <a:lstStyle/>
                     <a:p>
-                      <a:pPr algn="l" indent="0" marL="0">
+                      <a:pPr marL="0" indent="0" algn="l">
                         <a:buNone/>
                       </a:pPr>
                       <a:r>
@@ -3953,8 +3905,14 @@
                     <a:lnR w="0" cap="flat" cmpd="sng" algn="ctr">
                       <a:noFill/>
                     </a:lnR>
-                    <a:lnT w="0" cap="flat" cmpd="sng" algn="ctr">
-                      <a:noFill/>
+                    <a:lnT w="6350" cap="flat" cmpd="sng" algn="ctr">
+                      <a:solidFill>
+                        <a:srgbClr val="E3E3E3"/>
+                      </a:solidFill>
+                      <a:prstDash val="solid"/>
+                      <a:round/>
+                      <a:headEnd type="none" w="med" len="med"/>
+                      <a:tailEnd type="none" w="med" len="med"/>
                     </a:lnT>
                     <a:lnB w="6350" cap="flat" cmpd="sng" algn="ctr">
                       <a:solidFill>
@@ -3972,7 +3930,7 @@
                     <a:bodyPr/>
                     <a:lstStyle/>
                     <a:p>
-                      <a:pPr algn="l" indent="0" marL="0">
+                      <a:pPr marL="0" indent="0" algn="l">
                         <a:buNone/>
                       </a:pPr>
                       <a:r>
@@ -4000,8 +3958,14 @@
                     <a:lnR w="0" cap="flat" cmpd="sng" algn="ctr">
                       <a:noFill/>
                     </a:lnR>
-                    <a:lnT w="0" cap="flat" cmpd="sng" algn="ctr">
-                      <a:noFill/>
+                    <a:lnT w="6350" cap="flat" cmpd="sng" algn="ctr">
+                      <a:solidFill>
+                        <a:srgbClr val="E3E3E3"/>
+                      </a:solidFill>
+                      <a:prstDash val="solid"/>
+                      <a:round/>
+                      <a:headEnd type="none" w="med" len="med"/>
+                      <a:tailEnd type="none" w="med" len="med"/>
                     </a:lnT>
                     <a:lnB w="6350" cap="flat" cmpd="sng" algn="ctr">
                       <a:solidFill>
@@ -4019,7 +3983,7 @@
                     <a:bodyPr/>
                     <a:lstStyle/>
                     <a:p>
-                      <a:pPr algn="l" indent="0" marL="0">
+                      <a:pPr marL="0" indent="0" algn="l">
                         <a:buNone/>
                       </a:pPr>
                       <a:r>
@@ -4047,8 +4011,14 @@
                     <a:lnR w="0" cap="flat" cmpd="sng" algn="ctr">
                       <a:noFill/>
                     </a:lnR>
-                    <a:lnT w="0" cap="flat" cmpd="sng" algn="ctr">
-                      <a:noFill/>
+                    <a:lnT w="6350" cap="flat" cmpd="sng" algn="ctr">
+                      <a:solidFill>
+                        <a:srgbClr val="E3E3E3"/>
+                      </a:solidFill>
+                      <a:prstDash val="solid"/>
+                      <a:round/>
+                      <a:headEnd type="none" w="med" len="med"/>
+                      <a:tailEnd type="none" w="med" len="med"/>
                     </a:lnT>
                     <a:lnB w="6350" cap="flat" cmpd="sng" algn="ctr">
                       <a:solidFill>
@@ -4061,6 +4031,11 @@
                     </a:lnB>
                   </a:tcPr>
                 </a:tc>
+                <a:extLst>
+                  <a:ext uri="{0D108BD9-81ED-4DB2-BD59-A6C34878D82A}">
+                    <a16:rowId xmlns:a16="http://schemas.microsoft.com/office/drawing/2014/main" val="10003"/>
+                  </a:ext>
+                </a:extLst>
               </a:tr>
               <a:tr h="356616">
                 <a:tc>
@@ -4068,7 +4043,7 @@
                     <a:bodyPr/>
                     <a:lstStyle/>
                     <a:p>
-                      <a:pPr algn="l" indent="0" marL="0">
+                      <a:pPr marL="0" indent="0" algn="l">
                         <a:buNone/>
                       </a:pPr>
                       <a:r>
@@ -4096,8 +4071,14 @@
                     <a:lnR w="0" cap="flat" cmpd="sng" algn="ctr">
                       <a:noFill/>
                     </a:lnR>
-                    <a:lnT w="0" cap="flat" cmpd="sng" algn="ctr">
-                      <a:noFill/>
+                    <a:lnT w="6350" cap="flat" cmpd="sng" algn="ctr">
+                      <a:solidFill>
+                        <a:srgbClr val="E3E3E3"/>
+                      </a:solidFill>
+                      <a:prstDash val="solid"/>
+                      <a:round/>
+                      <a:headEnd type="none" w="med" len="med"/>
+                      <a:tailEnd type="none" w="med" len="med"/>
                     </a:lnT>
                     <a:lnB w="6350" cap="flat" cmpd="sng" algn="ctr">
                       <a:solidFill>
@@ -4115,7 +4096,7 @@
                     <a:bodyPr/>
                     <a:lstStyle/>
                     <a:p>
-                      <a:pPr algn="l" indent="0" marL="0">
+                      <a:pPr marL="0" indent="0" algn="l">
                         <a:buNone/>
                       </a:pPr>
                       <a:r>
@@ -4143,8 +4124,14 @@
                     <a:lnR w="0" cap="flat" cmpd="sng" algn="ctr">
                       <a:noFill/>
                     </a:lnR>
-                    <a:lnT w="0" cap="flat" cmpd="sng" algn="ctr">
-                      <a:noFill/>
+                    <a:lnT w="6350" cap="flat" cmpd="sng" algn="ctr">
+                      <a:solidFill>
+                        <a:srgbClr val="E3E3E3"/>
+                      </a:solidFill>
+                      <a:prstDash val="solid"/>
+                      <a:round/>
+                      <a:headEnd type="none" w="med" len="med"/>
+                      <a:tailEnd type="none" w="med" len="med"/>
                     </a:lnT>
                     <a:lnB w="6350" cap="flat" cmpd="sng" algn="ctr">
                       <a:solidFill>
@@ -4162,7 +4149,7 @@
                     <a:bodyPr/>
                     <a:lstStyle/>
                     <a:p>
-                      <a:pPr algn="l" indent="0" marL="0">
+                      <a:pPr marL="0" indent="0" algn="l">
                         <a:buNone/>
                       </a:pPr>
                       <a:r>
@@ -4174,7 +4161,7 @@
                           <a:ea typeface="Arial" pitchFamily="34" charset="-122"/>
                           <a:cs typeface="Arial" pitchFamily="34" charset="-120"/>
                         </a:rPr>
-                        <a:t>categories, k = 5</a:t>
+                        <a:t>categories</a:t>
                       </a:r>
                       <a:endParaRPr lang="en-US" sz="1300" dirty="0">
                         <a:latin typeface="Arial" charset="0"/>
@@ -4190,8 +4177,14 @@
                     <a:lnR w="0" cap="flat" cmpd="sng" algn="ctr">
                       <a:noFill/>
                     </a:lnR>
-                    <a:lnT w="0" cap="flat" cmpd="sng" algn="ctr">
-                      <a:noFill/>
+                    <a:lnT w="6350" cap="flat" cmpd="sng" algn="ctr">
+                      <a:solidFill>
+                        <a:srgbClr val="E3E3E3"/>
+                      </a:solidFill>
+                      <a:prstDash val="solid"/>
+                      <a:round/>
+                      <a:headEnd type="none" w="med" len="med"/>
+                      <a:tailEnd type="none" w="med" len="med"/>
                     </a:lnT>
                     <a:lnB w="6350" cap="flat" cmpd="sng" algn="ctr">
                       <a:solidFill>
@@ -4204,6 +4197,11 @@
                     </a:lnB>
                   </a:tcPr>
                 </a:tc>
+                <a:extLst>
+                  <a:ext uri="{0D108BD9-81ED-4DB2-BD59-A6C34878D82A}">
+                    <a16:rowId xmlns:a16="http://schemas.microsoft.com/office/drawing/2014/main" val="10004"/>
+                  </a:ext>
+                </a:extLst>
               </a:tr>
               <a:tr h="356616">
                 <a:tc>
@@ -4211,7 +4209,7 @@
                     <a:bodyPr/>
                     <a:lstStyle/>
                     <a:p>
-                      <a:pPr algn="l" indent="0" marL="0">
+                      <a:pPr marL="0" indent="0" algn="l">
                         <a:buNone/>
                       </a:pPr>
                       <a:r>
@@ -4239,8 +4237,14 @@
                     <a:lnR w="0" cap="flat" cmpd="sng" algn="ctr">
                       <a:noFill/>
                     </a:lnR>
-                    <a:lnT w="0" cap="flat" cmpd="sng" algn="ctr">
-                      <a:noFill/>
+                    <a:lnT w="6350" cap="flat" cmpd="sng" algn="ctr">
+                      <a:solidFill>
+                        <a:srgbClr val="E3E3E3"/>
+                      </a:solidFill>
+                      <a:prstDash val="solid"/>
+                      <a:round/>
+                      <a:headEnd type="none" w="med" len="med"/>
+                      <a:tailEnd type="none" w="med" len="med"/>
                     </a:lnT>
                     <a:lnB w="6350" cap="flat" cmpd="sng" algn="ctr">
                       <a:solidFill>
@@ -4258,7 +4262,7 @@
                     <a:bodyPr/>
                     <a:lstStyle/>
                     <a:p>
-                      <a:pPr algn="l" indent="0" marL="0">
+                      <a:pPr marL="0" indent="0" algn="l">
                         <a:buNone/>
                       </a:pPr>
                       <a:r>
@@ -4286,8 +4290,14 @@
                     <a:lnR w="0" cap="flat" cmpd="sng" algn="ctr">
                       <a:noFill/>
                     </a:lnR>
-                    <a:lnT w="0" cap="flat" cmpd="sng" algn="ctr">
-                      <a:noFill/>
+                    <a:lnT w="6350" cap="flat" cmpd="sng" algn="ctr">
+                      <a:solidFill>
+                        <a:srgbClr val="E3E3E3"/>
+                      </a:solidFill>
+                      <a:prstDash val="solid"/>
+                      <a:round/>
+                      <a:headEnd type="none" w="med" len="med"/>
+                      <a:tailEnd type="none" w="med" len="med"/>
                     </a:lnT>
                     <a:lnB w="6350" cap="flat" cmpd="sng" algn="ctr">
                       <a:solidFill>
@@ -4305,7 +4315,7 @@
                     <a:bodyPr/>
                     <a:lstStyle/>
                     <a:p>
-                      <a:pPr algn="l" indent="0" marL="0">
+                      <a:pPr marL="0" indent="0" algn="l">
                         <a:buNone/>
                       </a:pPr>
                       <a:r>
@@ -4333,8 +4343,14 @@
                     <a:lnR w="0" cap="flat" cmpd="sng" algn="ctr">
                       <a:noFill/>
                     </a:lnR>
-                    <a:lnT w="0" cap="flat" cmpd="sng" algn="ctr">
-                      <a:noFill/>
+                    <a:lnT w="6350" cap="flat" cmpd="sng" algn="ctr">
+                      <a:solidFill>
+                        <a:srgbClr val="E3E3E3"/>
+                      </a:solidFill>
+                      <a:prstDash val="solid"/>
+                      <a:round/>
+                      <a:headEnd type="none" w="med" len="med"/>
+                      <a:tailEnd type="none" w="med" len="med"/>
                     </a:lnT>
                     <a:lnB w="6350" cap="flat" cmpd="sng" algn="ctr">
                       <a:solidFill>
@@ -4347,6 +4363,11 @@
                     </a:lnB>
                   </a:tcPr>
                 </a:tc>
+                <a:extLst>
+                  <a:ext uri="{0D108BD9-81ED-4DB2-BD59-A6C34878D82A}">
+                    <a16:rowId xmlns:a16="http://schemas.microsoft.com/office/drawing/2014/main" val="10005"/>
+                  </a:ext>
+                </a:extLst>
               </a:tr>
               <a:tr h="356616">
                 <a:tc>
@@ -4354,7 +4375,7 @@
                     <a:bodyPr/>
                     <a:lstStyle/>
                     <a:p>
-                      <a:pPr algn="l" indent="0" marL="0">
+                      <a:pPr marL="0" indent="0" algn="l">
                         <a:buNone/>
                       </a:pPr>
                       <a:r>
@@ -4382,8 +4403,14 @@
                     <a:lnR w="0" cap="flat" cmpd="sng" algn="ctr">
                       <a:noFill/>
                     </a:lnR>
-                    <a:lnT w="0" cap="flat" cmpd="sng" algn="ctr">
-                      <a:noFill/>
+                    <a:lnT w="6350" cap="flat" cmpd="sng" algn="ctr">
+                      <a:solidFill>
+                        <a:srgbClr val="E3E3E3"/>
+                      </a:solidFill>
+                      <a:prstDash val="solid"/>
+                      <a:round/>
+                      <a:headEnd type="none" w="med" len="med"/>
+                      <a:tailEnd type="none" w="med" len="med"/>
                     </a:lnT>
                     <a:lnB w="6350" cap="flat" cmpd="sng" algn="ctr">
                       <a:solidFill>
@@ -4401,7 +4428,7 @@
                     <a:bodyPr/>
                     <a:lstStyle/>
                     <a:p>
-                      <a:pPr algn="l" indent="0" marL="0">
+                      <a:pPr marL="0" indent="0" algn="l">
                         <a:buNone/>
                       </a:pPr>
                       <a:r>
@@ -4429,8 +4456,14 @@
                     <a:lnR w="0" cap="flat" cmpd="sng" algn="ctr">
                       <a:noFill/>
                     </a:lnR>
-                    <a:lnT w="0" cap="flat" cmpd="sng" algn="ctr">
-                      <a:noFill/>
+                    <a:lnT w="6350" cap="flat" cmpd="sng" algn="ctr">
+                      <a:solidFill>
+                        <a:srgbClr val="E3E3E3"/>
+                      </a:solidFill>
+                      <a:prstDash val="solid"/>
+                      <a:round/>
+                      <a:headEnd type="none" w="med" len="med"/>
+                      <a:tailEnd type="none" w="med" len="med"/>
                     </a:lnT>
                     <a:lnB w="6350" cap="flat" cmpd="sng" algn="ctr">
                       <a:solidFill>
@@ -4448,7 +4481,7 @@
                     <a:bodyPr/>
                     <a:lstStyle/>
                     <a:p>
-                      <a:pPr algn="l" indent="0" marL="0">
+                      <a:pPr marL="0" indent="0" algn="l">
                         <a:buNone/>
                       </a:pPr>
                       <a:r>
@@ -4476,8 +4509,14 @@
                     <a:lnR w="0" cap="flat" cmpd="sng" algn="ctr">
                       <a:noFill/>
                     </a:lnR>
-                    <a:lnT w="0" cap="flat" cmpd="sng" algn="ctr">
-                      <a:noFill/>
+                    <a:lnT w="6350" cap="flat" cmpd="sng" algn="ctr">
+                      <a:solidFill>
+                        <a:srgbClr val="E3E3E3"/>
+                      </a:solidFill>
+                      <a:prstDash val="solid"/>
+                      <a:round/>
+                      <a:headEnd type="none" w="med" len="med"/>
+                      <a:tailEnd type="none" w="med" len="med"/>
                     </a:lnT>
                     <a:lnB w="6350" cap="flat" cmpd="sng" algn="ctr">
                       <a:solidFill>
@@ -4490,6 +4529,11 @@
                     </a:lnB>
                   </a:tcPr>
                 </a:tc>
+                <a:extLst>
+                  <a:ext uri="{0D108BD9-81ED-4DB2-BD59-A6C34878D82A}">
+                    <a16:rowId xmlns:a16="http://schemas.microsoft.com/office/drawing/2014/main" val="10006"/>
+                  </a:ext>
+                </a:extLst>
               </a:tr>
               <a:tr h="356616">
                 <a:tc>
@@ -4497,7 +4541,7 @@
                     <a:bodyPr/>
                     <a:lstStyle/>
                     <a:p>
-                      <a:pPr algn="l" indent="0" marL="0">
+                      <a:pPr marL="0" indent="0" algn="l">
                         <a:buNone/>
                       </a:pPr>
                       <a:r>
@@ -4525,8 +4569,14 @@
                     <a:lnR w="0" cap="flat" cmpd="sng" algn="ctr">
                       <a:noFill/>
                     </a:lnR>
-                    <a:lnT w="0" cap="flat" cmpd="sng" algn="ctr">
-                      <a:noFill/>
+                    <a:lnT w="6350" cap="flat" cmpd="sng" algn="ctr">
+                      <a:solidFill>
+                        <a:srgbClr val="E3E3E3"/>
+                      </a:solidFill>
+                      <a:prstDash val="solid"/>
+                      <a:round/>
+                      <a:headEnd type="none" w="med" len="med"/>
+                      <a:tailEnd type="none" w="med" len="med"/>
                     </a:lnT>
                     <a:lnB w="6350" cap="flat" cmpd="sng" algn="ctr">
                       <a:solidFill>
@@ -4544,7 +4594,7 @@
                     <a:bodyPr/>
                     <a:lstStyle/>
                     <a:p>
-                      <a:pPr algn="l" indent="0" marL="0">
+                      <a:pPr marL="0" indent="0" algn="l">
                         <a:buNone/>
                       </a:pPr>
                       <a:r>
@@ -4572,8 +4622,14 @@
                     <a:lnR w="0" cap="flat" cmpd="sng" algn="ctr">
                       <a:noFill/>
                     </a:lnR>
-                    <a:lnT w="0" cap="flat" cmpd="sng" algn="ctr">
-                      <a:noFill/>
+                    <a:lnT w="6350" cap="flat" cmpd="sng" algn="ctr">
+                      <a:solidFill>
+                        <a:srgbClr val="E3E3E3"/>
+                      </a:solidFill>
+                      <a:prstDash val="solid"/>
+                      <a:round/>
+                      <a:headEnd type="none" w="med" len="med"/>
+                      <a:tailEnd type="none" w="med" len="med"/>
                     </a:lnT>
                     <a:lnB w="6350" cap="flat" cmpd="sng" algn="ctr">
                       <a:solidFill>
@@ -4591,7 +4647,7 @@
                     <a:bodyPr/>
                     <a:lstStyle/>
                     <a:p>
-                      <a:pPr algn="l" indent="0" marL="0">
+                      <a:pPr marL="0" indent="0" algn="l">
                         <a:buNone/>
                       </a:pPr>
                       <a:r>
@@ -4619,8 +4675,14 @@
                     <a:lnR w="0" cap="flat" cmpd="sng" algn="ctr">
                       <a:noFill/>
                     </a:lnR>
-                    <a:lnT w="0" cap="flat" cmpd="sng" algn="ctr">
-                      <a:noFill/>
+                    <a:lnT w="6350" cap="flat" cmpd="sng" algn="ctr">
+                      <a:solidFill>
+                        <a:srgbClr val="E3E3E3"/>
+                      </a:solidFill>
+                      <a:prstDash val="solid"/>
+                      <a:round/>
+                      <a:headEnd type="none" w="med" len="med"/>
+                      <a:tailEnd type="none" w="med" len="med"/>
                     </a:lnT>
                     <a:lnB w="6350" cap="flat" cmpd="sng" algn="ctr">
                       <a:solidFill>
@@ -4633,6 +4695,11 @@
                     </a:lnB>
                   </a:tcPr>
                 </a:tc>
+                <a:extLst>
+                  <a:ext uri="{0D108BD9-81ED-4DB2-BD59-A6C34878D82A}">
+                    <a16:rowId xmlns:a16="http://schemas.microsoft.com/office/drawing/2014/main" val="10007"/>
+                  </a:ext>
+                </a:extLst>
               </a:tr>
               <a:tr h="356616">
                 <a:tc>
@@ -4640,7 +4707,7 @@
                     <a:bodyPr/>
                     <a:lstStyle/>
                     <a:p>
-                      <a:pPr algn="l" indent="0" marL="0">
+                      <a:pPr marL="0" indent="0" algn="l">
                         <a:buNone/>
                       </a:pPr>
                       <a:r>
@@ -4668,8 +4735,14 @@
                     <a:lnR w="0" cap="flat" cmpd="sng" algn="ctr">
                       <a:noFill/>
                     </a:lnR>
-                    <a:lnT w="0" cap="flat" cmpd="sng" algn="ctr">
-                      <a:noFill/>
+                    <a:lnT w="6350" cap="flat" cmpd="sng" algn="ctr">
+                      <a:solidFill>
+                        <a:srgbClr val="E3E3E3"/>
+                      </a:solidFill>
+                      <a:prstDash val="solid"/>
+                      <a:round/>
+                      <a:headEnd type="none" w="med" len="med"/>
+                      <a:tailEnd type="none" w="med" len="med"/>
                     </a:lnT>
                     <a:lnB w="15875" cap="flat" cmpd="sng" algn="ctr">
                       <a:solidFill>
@@ -4687,7 +4760,7 @@
                     <a:bodyPr/>
                     <a:lstStyle/>
                     <a:p>
-                      <a:pPr algn="l" indent="0" marL="0">
+                      <a:pPr marL="0" indent="0" algn="l">
                         <a:buNone/>
                       </a:pPr>
                       <a:r>
@@ -4715,8 +4788,14 @@
                     <a:lnR w="0" cap="flat" cmpd="sng" algn="ctr">
                       <a:noFill/>
                     </a:lnR>
-                    <a:lnT w="0" cap="flat" cmpd="sng" algn="ctr">
-                      <a:noFill/>
+                    <a:lnT w="6350" cap="flat" cmpd="sng" algn="ctr">
+                      <a:solidFill>
+                        <a:srgbClr val="E3E3E3"/>
+                      </a:solidFill>
+                      <a:prstDash val="solid"/>
+                      <a:round/>
+                      <a:headEnd type="none" w="med" len="med"/>
+                      <a:tailEnd type="none" w="med" len="med"/>
                     </a:lnT>
                     <a:lnB w="15875" cap="flat" cmpd="sng" algn="ctr">
                       <a:solidFill>
@@ -4734,7 +4813,7 @@
                     <a:bodyPr/>
                     <a:lstStyle/>
                     <a:p>
-                      <a:pPr algn="l" indent="0" marL="0">
+                      <a:pPr marL="0" indent="0" algn="l">
                         <a:buNone/>
                       </a:pPr>
                       <a:r>
@@ -4762,8 +4841,14 @@
                     <a:lnR w="0" cap="flat" cmpd="sng" algn="ctr">
                       <a:noFill/>
                     </a:lnR>
-                    <a:lnT w="0" cap="flat" cmpd="sng" algn="ctr">
-                      <a:noFill/>
+                    <a:lnT w="6350" cap="flat" cmpd="sng" algn="ctr">
+                      <a:solidFill>
+                        <a:srgbClr val="E3E3E3"/>
+                      </a:solidFill>
+                      <a:prstDash val="solid"/>
+                      <a:round/>
+                      <a:headEnd type="none" w="med" len="med"/>
+                      <a:tailEnd type="none" w="med" len="med"/>
                     </a:lnT>
                     <a:lnB w="15875" cap="flat" cmpd="sng" algn="ctr">
                       <a:solidFill>
@@ -4776,6 +4861,11 @@
                     </a:lnB>
                   </a:tcPr>
                 </a:tc>
+                <a:extLst>
+                  <a:ext uri="{0D108BD9-81ED-4DB2-BD59-A6C34878D82A}">
+                    <a16:rowId xmlns:a16="http://schemas.microsoft.com/office/drawing/2014/main" val="10008"/>
+                  </a:ext>
+                </a:extLst>
               </a:tr>
             </a:tbl>
           </a:graphicData>
@@ -4801,7 +4891,7 @@
           </a:prstGeom>
           <a:extLst>
             <a:ext uri="{C572A759-6A51-4108-AA02-DFA0A04FC94B}">
-              <ma14:wrappingTextBoxFlag xmlns:ma14="http://schemas.microsoft.com/office/mac/drawingml/2011/main" val="0"/>
+              <ma14:wrappingTextBoxFlag xmlns:ma14="http://schemas.microsoft.com/office/mac/drawingml/2011/main" xmlns="" val="0"/>
             </a:ext>
           </a:extLst>
         </p:spPr>
@@ -4819,7 +4909,7 @@
           <a:p>
             <a:pPr algn="r"/>
             <a:fld id="{F7021451-1387-4CA6-816F-3879F97B5CBC}" type="slidenum">
-              <a:rPr b="0" lang="en-US"/>
+              <a:rPr lang="en-US" b="0"/>
               <a:t>3</a:t>
             </a:fld>
             <a:endParaRPr lang="en-US"/>
@@ -4854,9 +4944,11 @@
       <p:sp>
         <p:nvSpPr>
           <p:cNvPr id="2" name="Text 0"/>
-          <p:cNvSpPr/>
+          <p:cNvSpPr>
+            <a:spLocks noGrp="1"/>
+          </p:cNvSpPr>
           <p:nvPr>
-            <p:ph idx="100" type="title" hasCustomPrompt="1"/>
+            <p:ph type="title" idx="100" hasCustomPrompt="1"/>
           </p:nvPr>
         </p:nvSpPr>
         <p:spPr>
@@ -4874,7 +4966,7 @@
           <a:bodyPr wrap="square" lIns="0" tIns="0" rIns="0" bIns="0" rtlCol="0" anchor="ctr"/>
           <a:lstStyle/>
           <a:p>
-            <a:pPr algn="l" indent="0" marL="0">
+            <a:pPr marL="0" indent="0" algn="l">
               <a:buNone/>
             </a:pPr>
             <a:r>
@@ -5009,14 +5101,14 @@
       </p:sp>
       <p:pic>
         <p:nvPicPr>
-          <p:cNvPr id="4" name="reviews per user figure" descr="/mnt/user-data/uploads/PPIA_HW1/figures/03_reviews_per_user.png">    </p:cNvPr>
+          <p:cNvPr id="4" name="reviews per user figure" descr="/mnt/user-data/uploads/PPIA_HW1/figures/03_reviews_per_user.png"/>
           <p:cNvPicPr>
             <a:picLocks noChangeAspect="1"/>
           </p:cNvPicPr>
           <p:nvPr/>
         </p:nvPicPr>
         <p:blipFill>
-          <a:blip r:embed="rId1"/>
+          <a:blip r:embed="rId3"/>
           <a:stretch>
             <a:fillRect/>
           </a:stretch>
@@ -5031,42 +5123,6 @@
           </a:prstGeom>
         </p:spPr>
       </p:pic>
-      <p:sp>
-        <p:nvSpPr>
-          <p:cNvPr id="5" name="Text 2"/>
-          <p:cNvSpPr txBox="1"/>
-          <p:nvPr/>
-        </p:nvSpPr>
-        <p:spPr>
-          <a:xfrm>
-            <a:off x="4114800" y="3840480"/>
-            <a:ext cx="4480560" cy="228600"/>
-          </a:xfrm>
-          <a:prstGeom prst="rect">
-            <a:avLst/>
-          </a:prstGeom>
-          <a:noFill/>
-          <a:ln/>
-        </p:spPr>
-        <p:txBody>
-          <a:bodyPr wrap="square" lIns="0" tIns="0" rIns="0" bIns="0" rtlCol="0" anchor="t"/>
-          <a:lstStyle/>
-          <a:p>
-            <a:pPr indent="0" marL="0">
-              <a:buNone/>
-            </a:pPr>
-            <a:r>
-              <a:rPr lang="en-US" sz="1000" i="1" dirty="0">
-                <a:solidFill>
-                  <a:schemeClr val="tx2"/>
-                </a:solidFill>
-              </a:rPr>
-              <a:t>Reviews written per user, Vermont</a:t>
-            </a:r>
-            <a:endParaRPr lang="en-US" sz="1000" dirty="0"/>
-          </a:p>
-        </p:txBody>
-      </p:sp>
       <p:sp>
         <p:nvSpPr>
           <p:cNvPr id="25" name="Slide Number Placeholder 0"/>
@@ -5087,7 +5143,7 @@
           </a:prstGeom>
           <a:extLst>
             <a:ext uri="{C572A759-6A51-4108-AA02-DFA0A04FC94B}">
-              <ma14:wrappingTextBoxFlag xmlns:ma14="http://schemas.microsoft.com/office/mac/drawingml/2011/main" val="0"/>
+              <ma14:wrappingTextBoxFlag xmlns:ma14="http://schemas.microsoft.com/office/mac/drawingml/2011/main" xmlns="" val="0"/>
             </a:ext>
           </a:extLst>
         </p:spPr>
@@ -5105,7 +5161,7 @@
           <a:p>
             <a:pPr algn="r"/>
             <a:fld id="{F7021451-1387-4CA6-816F-3879F97B5CBC}" type="slidenum">
-              <a:rPr b="0" lang="en-US"/>
+              <a:rPr lang="en-US" b="0"/>
               <a:t>4</a:t>
             </a:fld>
             <a:endParaRPr lang="en-US"/>
@@ -5140,9 +5196,11 @@
       <p:sp>
         <p:nvSpPr>
           <p:cNvPr id="2" name="Text 0"/>
-          <p:cNvSpPr/>
+          <p:cNvSpPr>
+            <a:spLocks noGrp="1"/>
+          </p:cNvSpPr>
           <p:nvPr>
-            <p:ph idx="100" type="title" hasCustomPrompt="1"/>
+            <p:ph type="title" idx="100" hasCustomPrompt="1"/>
           </p:nvPr>
         </p:nvSpPr>
         <p:spPr>
@@ -5160,7 +5218,7 @@
           <a:bodyPr wrap="square" lIns="0" tIns="0" rIns="0" bIns="0" rtlCol="0" anchor="ctr"/>
           <a:lstStyle/>
           <a:p>
-            <a:pPr algn="l" indent="0" marL="0">
+            <a:pPr marL="0" indent="0" algn="l">
               <a:buNone/>
             </a:pPr>
             <a:r>
@@ -5196,7 +5254,7 @@
           <a:bodyPr wrap="square" lIns="0" tIns="0" rIns="0" bIns="0" rtlCol="0" anchor="t"/>
           <a:lstStyle/>
           <a:p>
-            <a:pPr indent="0" marL="0">
+            <a:pPr marL="0" indent="0">
               <a:buNone/>
             </a:pPr>
             <a:r>
@@ -5326,7 +5384,7 @@
           <a:bodyPr wrap="square" lIns="0" tIns="0" rIns="0" bIns="0" rtlCol="0" anchor="t"/>
           <a:lstStyle/>
           <a:p>
-            <a:pPr indent="0" marL="0">
+            <a:pPr marL="0" indent="0">
               <a:buNone/>
             </a:pPr>
             <a:r>
@@ -5479,7 +5537,7 @@
           </a:prstGeom>
           <a:extLst>
             <a:ext uri="{C572A759-6A51-4108-AA02-DFA0A04FC94B}">
-              <ma14:wrappingTextBoxFlag xmlns:ma14="http://schemas.microsoft.com/office/mac/drawingml/2011/main" val="0"/>
+              <ma14:wrappingTextBoxFlag xmlns:ma14="http://schemas.microsoft.com/office/mac/drawingml/2011/main" xmlns="" val="0"/>
             </a:ext>
           </a:extLst>
         </p:spPr>
@@ -5497,7 +5555,7 @@
           <a:p>
             <a:pPr algn="r"/>
             <a:fld id="{F7021451-1387-4CA6-816F-3879F97B5CBC}" type="slidenum">
-              <a:rPr b="0" lang="en-US"/>
+              <a:rPr lang="en-US" b="0"/>
               <a:t>5</a:t>
             </a:fld>
             <a:endParaRPr lang="en-US"/>
@@ -5532,9 +5590,11 @@
       <p:sp>
         <p:nvSpPr>
           <p:cNvPr id="2" name="Text 0"/>
-          <p:cNvSpPr/>
+          <p:cNvSpPr>
+            <a:spLocks noGrp="1"/>
+          </p:cNvSpPr>
           <p:nvPr>
-            <p:ph idx="100" type="title" hasCustomPrompt="1"/>
+            <p:ph type="title" idx="100" hasCustomPrompt="1"/>
           </p:nvPr>
         </p:nvSpPr>
         <p:spPr>
@@ -5552,7 +5612,7 @@
           <a:bodyPr wrap="square" lIns="0" tIns="0" rIns="0" bIns="0" rtlCol="0" anchor="ctr"/>
           <a:lstStyle/>
           <a:p>
-            <a:pPr algn="l" indent="0" marL="0">
+            <a:pPr marL="0" indent="0" algn="l">
               <a:buNone/>
             </a:pPr>
             <a:r>
@@ -5588,7 +5648,7 @@
           <a:bodyPr wrap="square" lIns="0" tIns="0" rIns="0" bIns="0" rtlCol="0" anchor="t"/>
           <a:lstStyle/>
           <a:p>
-            <a:pPr indent="0" marL="0">
+            <a:pPr marL="0" indent="0">
               <a:buNone/>
             </a:pPr>
             <a:r>
@@ -5624,7 +5684,7 @@
           <a:bodyPr wrap="square" lIns="0" tIns="0" rIns="0" bIns="0" rtlCol="0" anchor="t"/>
           <a:lstStyle/>
           <a:p>
-            <a:pPr indent="0" marL="0">
+            <a:pPr marL="0" indent="0">
               <a:buNone/>
             </a:pPr>
             <a:r>
@@ -5655,16 +5715,34 @@
         </p:nvGraphicFramePr>
         <p:xfrm>
           <a:off x="548640" y="1691640"/>
-          <a:ext cx="4206240" cy="914400"/>
+          <a:ext cx="4206240" cy="2633472"/>
         </p:xfrm>
         <a:graphic>
           <a:graphicData uri="http://schemas.openxmlformats.org/drawingml/2006/table">
             <a:tbl>
               <a:tblPr/>
               <a:tblGrid>
-                <a:gridCol w="1828800"/>
-                <a:gridCol w="1188720"/>
-                <a:gridCol w="1188720"/>
+                <a:gridCol w="1828800">
+                  <a:extLst>
+                    <a:ext uri="{9D8B030D-6E8A-4147-A177-3AD203B41FA5}">
+                      <a16:colId xmlns:a16="http://schemas.microsoft.com/office/drawing/2014/main" val="20000"/>
+                    </a:ext>
+                  </a:extLst>
+                </a:gridCol>
+                <a:gridCol w="1188720">
+                  <a:extLst>
+                    <a:ext uri="{9D8B030D-6E8A-4147-A177-3AD203B41FA5}">
+                      <a16:colId xmlns:a16="http://schemas.microsoft.com/office/drawing/2014/main" val="20001"/>
+                    </a:ext>
+                  </a:extLst>
+                </a:gridCol>
+                <a:gridCol w="1188720">
+                  <a:extLst>
+                    <a:ext uri="{9D8B030D-6E8A-4147-A177-3AD203B41FA5}">
+                      <a16:colId xmlns:a16="http://schemas.microsoft.com/office/drawing/2014/main" val="20002"/>
+                    </a:ext>
+                  </a:extLst>
+                </a:gridCol>
               </a:tblGrid>
               <a:tr h="329184">
                 <a:tc>
@@ -5672,7 +5750,7 @@
                     <a:bodyPr/>
                     <a:lstStyle/>
                     <a:p>
-                      <a:pPr algn="l" indent="0" marL="0">
+                      <a:pPr marL="0" indent="0" algn="l">
                         <a:buNone/>
                       </a:pPr>
                       <a:r>
@@ -5725,7 +5803,7 @@
                     <a:bodyPr/>
                     <a:lstStyle/>
                     <a:p>
-                      <a:pPr algn="r" indent="0" marL="0">
+                      <a:pPr marL="0" indent="0" algn="r">
                         <a:buNone/>
                       </a:pPr>
                       <a:r>
@@ -5778,7 +5856,7 @@
                     <a:bodyPr/>
                     <a:lstStyle/>
                     <a:p>
-                      <a:pPr algn="r" indent="0" marL="0">
+                      <a:pPr marL="0" indent="0" algn="r">
                         <a:buNone/>
                       </a:pPr>
                       <a:r>
@@ -5826,6 +5904,11 @@
                     </a:lnB>
                   </a:tcPr>
                 </a:tc>
+                <a:extLst>
+                  <a:ext uri="{0D108BD9-81ED-4DB2-BD59-A6C34878D82A}">
+                    <a16:rowId xmlns:a16="http://schemas.microsoft.com/office/drawing/2014/main" val="10000"/>
+                  </a:ext>
+                </a:extLst>
               </a:tr>
               <a:tr h="329184">
                 <a:tc>
@@ -5833,7 +5916,7 @@
                     <a:bodyPr/>
                     <a:lstStyle/>
                     <a:p>
-                      <a:pPr algn="l" indent="0" marL="0">
+                      <a:pPr marL="0" indent="0" algn="l">
                         <a:buNone/>
                       </a:pPr>
                       <a:r>
@@ -5861,8 +5944,14 @@
                     <a:lnR w="0" cap="flat" cmpd="sng" algn="ctr">
                       <a:noFill/>
                     </a:lnR>
-                    <a:lnT w="0" cap="flat" cmpd="sng" algn="ctr">
-                      <a:noFill/>
+                    <a:lnT w="9525" cap="flat" cmpd="sng" algn="ctr">
+                      <a:solidFill>
+                        <a:srgbClr val="222222"/>
+                      </a:solidFill>
+                      <a:prstDash val="solid"/>
+                      <a:round/>
+                      <a:headEnd type="none" w="med" len="med"/>
+                      <a:tailEnd type="none" w="med" len="med"/>
                     </a:lnT>
                     <a:lnB w="6350" cap="flat" cmpd="sng" algn="ctr">
                       <a:solidFill>
@@ -5880,7 +5969,7 @@
                     <a:bodyPr/>
                     <a:lstStyle/>
                     <a:p>
-                      <a:pPr algn="r" indent="0" marL="0">
+                      <a:pPr marL="0" indent="0" algn="r">
                         <a:buNone/>
                       </a:pPr>
                       <a:r>
@@ -5908,8 +5997,14 @@
                     <a:lnR w="0" cap="flat" cmpd="sng" algn="ctr">
                       <a:noFill/>
                     </a:lnR>
-                    <a:lnT w="0" cap="flat" cmpd="sng" algn="ctr">
-                      <a:noFill/>
+                    <a:lnT w="9525" cap="flat" cmpd="sng" algn="ctr">
+                      <a:solidFill>
+                        <a:srgbClr val="222222"/>
+                      </a:solidFill>
+                      <a:prstDash val="solid"/>
+                      <a:round/>
+                      <a:headEnd type="none" w="med" len="med"/>
+                      <a:tailEnd type="none" w="med" len="med"/>
                     </a:lnT>
                     <a:lnB w="6350" cap="flat" cmpd="sng" algn="ctr">
                       <a:solidFill>
@@ -5927,7 +6022,7 @@
                     <a:bodyPr/>
                     <a:lstStyle/>
                     <a:p>
-                      <a:pPr algn="r" indent="0" marL="0">
+                      <a:pPr marL="0" indent="0" algn="r">
                         <a:buNone/>
                       </a:pPr>
                       <a:r>
@@ -5955,8 +6050,14 @@
                     <a:lnR w="0" cap="flat" cmpd="sng" algn="ctr">
                       <a:noFill/>
                     </a:lnR>
-                    <a:lnT w="0" cap="flat" cmpd="sng" algn="ctr">
-                      <a:noFill/>
+                    <a:lnT w="9525" cap="flat" cmpd="sng" algn="ctr">
+                      <a:solidFill>
+                        <a:srgbClr val="222222"/>
+                      </a:solidFill>
+                      <a:prstDash val="solid"/>
+                      <a:round/>
+                      <a:headEnd type="none" w="med" len="med"/>
+                      <a:tailEnd type="none" w="med" len="med"/>
                     </a:lnT>
                     <a:lnB w="6350" cap="flat" cmpd="sng" algn="ctr">
                       <a:solidFill>
@@ -5969,6 +6070,11 @@
                     </a:lnB>
                   </a:tcPr>
                 </a:tc>
+                <a:extLst>
+                  <a:ext uri="{0D108BD9-81ED-4DB2-BD59-A6C34878D82A}">
+                    <a16:rowId xmlns:a16="http://schemas.microsoft.com/office/drawing/2014/main" val="10001"/>
+                  </a:ext>
+                </a:extLst>
               </a:tr>
               <a:tr h="329184">
                 <a:tc>
@@ -5976,7 +6082,7 @@
                     <a:bodyPr/>
                     <a:lstStyle/>
                     <a:p>
-                      <a:pPr algn="l" indent="0" marL="0">
+                      <a:pPr marL="0" indent="0" algn="l">
                         <a:buNone/>
                       </a:pPr>
                       <a:r>
@@ -6004,8 +6110,14 @@
                     <a:lnR w="0" cap="flat" cmpd="sng" algn="ctr">
                       <a:noFill/>
                     </a:lnR>
-                    <a:lnT w="0" cap="flat" cmpd="sng" algn="ctr">
-                      <a:noFill/>
+                    <a:lnT w="6350" cap="flat" cmpd="sng" algn="ctr">
+                      <a:solidFill>
+                        <a:srgbClr val="E3E3E3"/>
+                      </a:solidFill>
+                      <a:prstDash val="solid"/>
+                      <a:round/>
+                      <a:headEnd type="none" w="med" len="med"/>
+                      <a:tailEnd type="none" w="med" len="med"/>
                     </a:lnT>
                     <a:lnB w="6350" cap="flat" cmpd="sng" algn="ctr">
                       <a:solidFill>
@@ -6023,7 +6135,7 @@
                     <a:bodyPr/>
                     <a:lstStyle/>
                     <a:p>
-                      <a:pPr algn="r" indent="0" marL="0">
+                      <a:pPr marL="0" indent="0" algn="r">
                         <a:buNone/>
                       </a:pPr>
                       <a:r>
@@ -6051,8 +6163,14 @@
                     <a:lnR w="0" cap="flat" cmpd="sng" algn="ctr">
                       <a:noFill/>
                     </a:lnR>
-                    <a:lnT w="0" cap="flat" cmpd="sng" algn="ctr">
-                      <a:noFill/>
+                    <a:lnT w="6350" cap="flat" cmpd="sng" algn="ctr">
+                      <a:solidFill>
+                        <a:srgbClr val="E3E3E3"/>
+                      </a:solidFill>
+                      <a:prstDash val="solid"/>
+                      <a:round/>
+                      <a:headEnd type="none" w="med" len="med"/>
+                      <a:tailEnd type="none" w="med" len="med"/>
                     </a:lnT>
                     <a:lnB w="6350" cap="flat" cmpd="sng" algn="ctr">
                       <a:solidFill>
@@ -6070,7 +6188,7 @@
                     <a:bodyPr/>
                     <a:lstStyle/>
                     <a:p>
-                      <a:pPr algn="r" indent="0" marL="0">
+                      <a:pPr marL="0" indent="0" algn="r">
                         <a:buNone/>
                       </a:pPr>
                       <a:r>
@@ -6098,8 +6216,14 @@
                     <a:lnR w="0" cap="flat" cmpd="sng" algn="ctr">
                       <a:noFill/>
                     </a:lnR>
-                    <a:lnT w="0" cap="flat" cmpd="sng" algn="ctr">
-                      <a:noFill/>
+                    <a:lnT w="6350" cap="flat" cmpd="sng" algn="ctr">
+                      <a:solidFill>
+                        <a:srgbClr val="E3E3E3"/>
+                      </a:solidFill>
+                      <a:prstDash val="solid"/>
+                      <a:round/>
+                      <a:headEnd type="none" w="med" len="med"/>
+                      <a:tailEnd type="none" w="med" len="med"/>
                     </a:lnT>
                     <a:lnB w="6350" cap="flat" cmpd="sng" algn="ctr">
                       <a:solidFill>
@@ -6112,6 +6236,11 @@
                     </a:lnB>
                   </a:tcPr>
                 </a:tc>
+                <a:extLst>
+                  <a:ext uri="{0D108BD9-81ED-4DB2-BD59-A6C34878D82A}">
+                    <a16:rowId xmlns:a16="http://schemas.microsoft.com/office/drawing/2014/main" val="10002"/>
+                  </a:ext>
+                </a:extLst>
               </a:tr>
               <a:tr h="329184">
                 <a:tc>
@@ -6119,7 +6248,7 @@
                     <a:bodyPr/>
                     <a:lstStyle/>
                     <a:p>
-                      <a:pPr algn="l" indent="0" marL="0">
+                      <a:pPr marL="0" indent="0" algn="l">
                         <a:buNone/>
                       </a:pPr>
                       <a:r>
@@ -6147,8 +6276,14 @@
                     <a:lnR w="0" cap="flat" cmpd="sng" algn="ctr">
                       <a:noFill/>
                     </a:lnR>
-                    <a:lnT w="0" cap="flat" cmpd="sng" algn="ctr">
-                      <a:noFill/>
+                    <a:lnT w="6350" cap="flat" cmpd="sng" algn="ctr">
+                      <a:solidFill>
+                        <a:srgbClr val="E3E3E3"/>
+                      </a:solidFill>
+                      <a:prstDash val="solid"/>
+                      <a:round/>
+                      <a:headEnd type="none" w="med" len="med"/>
+                      <a:tailEnd type="none" w="med" len="med"/>
                     </a:lnT>
                     <a:lnB w="6350" cap="flat" cmpd="sng" algn="ctr">
                       <a:solidFill>
@@ -6166,7 +6301,7 @@
                     <a:bodyPr/>
                     <a:lstStyle/>
                     <a:p>
-                      <a:pPr algn="r" indent="0" marL="0">
+                      <a:pPr marL="0" indent="0" algn="r">
                         <a:buNone/>
                       </a:pPr>
                       <a:r>
@@ -6194,8 +6329,14 @@
                     <a:lnR w="0" cap="flat" cmpd="sng" algn="ctr">
                       <a:noFill/>
                     </a:lnR>
-                    <a:lnT w="0" cap="flat" cmpd="sng" algn="ctr">
-                      <a:noFill/>
+                    <a:lnT w="6350" cap="flat" cmpd="sng" algn="ctr">
+                      <a:solidFill>
+                        <a:srgbClr val="E3E3E3"/>
+                      </a:solidFill>
+                      <a:prstDash val="solid"/>
+                      <a:round/>
+                      <a:headEnd type="none" w="med" len="med"/>
+                      <a:tailEnd type="none" w="med" len="med"/>
                     </a:lnT>
                     <a:lnB w="6350" cap="flat" cmpd="sng" algn="ctr">
                       <a:solidFill>
@@ -6213,7 +6354,7 @@
                     <a:bodyPr/>
                     <a:lstStyle/>
                     <a:p>
-                      <a:pPr algn="r" indent="0" marL="0">
+                      <a:pPr marL="0" indent="0" algn="r">
                         <a:buNone/>
                       </a:pPr>
                       <a:r>
@@ -6241,8 +6382,14 @@
                     <a:lnR w="0" cap="flat" cmpd="sng" algn="ctr">
                       <a:noFill/>
                     </a:lnR>
-                    <a:lnT w="0" cap="flat" cmpd="sng" algn="ctr">
-                      <a:noFill/>
+                    <a:lnT w="6350" cap="flat" cmpd="sng" algn="ctr">
+                      <a:solidFill>
+                        <a:srgbClr val="E3E3E3"/>
+                      </a:solidFill>
+                      <a:prstDash val="solid"/>
+                      <a:round/>
+                      <a:headEnd type="none" w="med" len="med"/>
+                      <a:tailEnd type="none" w="med" len="med"/>
                     </a:lnT>
                     <a:lnB w="6350" cap="flat" cmpd="sng" algn="ctr">
                       <a:solidFill>
@@ -6255,6 +6402,11 @@
                     </a:lnB>
                   </a:tcPr>
                 </a:tc>
+                <a:extLst>
+                  <a:ext uri="{0D108BD9-81ED-4DB2-BD59-A6C34878D82A}">
+                    <a16:rowId xmlns:a16="http://schemas.microsoft.com/office/drawing/2014/main" val="10003"/>
+                  </a:ext>
+                </a:extLst>
               </a:tr>
               <a:tr h="329184">
                 <a:tc>
@@ -6262,7 +6414,7 @@
                     <a:bodyPr/>
                     <a:lstStyle/>
                     <a:p>
-                      <a:pPr algn="l" indent="0" marL="0">
+                      <a:pPr marL="0" indent="0" algn="l">
                         <a:buNone/>
                       </a:pPr>
                       <a:r>
@@ -6290,8 +6442,14 @@
                     <a:lnR w="0" cap="flat" cmpd="sng" algn="ctr">
                       <a:noFill/>
                     </a:lnR>
-                    <a:lnT w="0" cap="flat" cmpd="sng" algn="ctr">
-                      <a:noFill/>
+                    <a:lnT w="6350" cap="flat" cmpd="sng" algn="ctr">
+                      <a:solidFill>
+                        <a:srgbClr val="E3E3E3"/>
+                      </a:solidFill>
+                      <a:prstDash val="solid"/>
+                      <a:round/>
+                      <a:headEnd type="none" w="med" len="med"/>
+                      <a:tailEnd type="none" w="med" len="med"/>
                     </a:lnT>
                     <a:lnB w="6350" cap="flat" cmpd="sng" algn="ctr">
                       <a:solidFill>
@@ -6309,7 +6467,7 @@
                     <a:bodyPr/>
                     <a:lstStyle/>
                     <a:p>
-                      <a:pPr algn="r" indent="0" marL="0">
+                      <a:pPr marL="0" indent="0" algn="r">
                         <a:buNone/>
                       </a:pPr>
                       <a:r>
@@ -6337,8 +6495,14 @@
                     <a:lnR w="0" cap="flat" cmpd="sng" algn="ctr">
                       <a:noFill/>
                     </a:lnR>
-                    <a:lnT w="0" cap="flat" cmpd="sng" algn="ctr">
-                      <a:noFill/>
+                    <a:lnT w="6350" cap="flat" cmpd="sng" algn="ctr">
+                      <a:solidFill>
+                        <a:srgbClr val="E3E3E3"/>
+                      </a:solidFill>
+                      <a:prstDash val="solid"/>
+                      <a:round/>
+                      <a:headEnd type="none" w="med" len="med"/>
+                      <a:tailEnd type="none" w="med" len="med"/>
                     </a:lnT>
                     <a:lnB w="6350" cap="flat" cmpd="sng" algn="ctr">
                       <a:solidFill>
@@ -6356,7 +6520,7 @@
                     <a:bodyPr/>
                     <a:lstStyle/>
                     <a:p>
-                      <a:pPr algn="r" indent="0" marL="0">
+                      <a:pPr marL="0" indent="0" algn="r">
                         <a:buNone/>
                       </a:pPr>
                       <a:r>
@@ -6384,8 +6548,14 @@
                     <a:lnR w="0" cap="flat" cmpd="sng" algn="ctr">
                       <a:noFill/>
                     </a:lnR>
-                    <a:lnT w="0" cap="flat" cmpd="sng" algn="ctr">
-                      <a:noFill/>
+                    <a:lnT w="6350" cap="flat" cmpd="sng" algn="ctr">
+                      <a:solidFill>
+                        <a:srgbClr val="E3E3E3"/>
+                      </a:solidFill>
+                      <a:prstDash val="solid"/>
+                      <a:round/>
+                      <a:headEnd type="none" w="med" len="med"/>
+                      <a:tailEnd type="none" w="med" len="med"/>
                     </a:lnT>
                     <a:lnB w="6350" cap="flat" cmpd="sng" algn="ctr">
                       <a:solidFill>
@@ -6398,6 +6568,11 @@
                     </a:lnB>
                   </a:tcPr>
                 </a:tc>
+                <a:extLst>
+                  <a:ext uri="{0D108BD9-81ED-4DB2-BD59-A6C34878D82A}">
+                    <a16:rowId xmlns:a16="http://schemas.microsoft.com/office/drawing/2014/main" val="10004"/>
+                  </a:ext>
+                </a:extLst>
               </a:tr>
               <a:tr h="329184">
                 <a:tc>
@@ -6405,7 +6580,7 @@
                     <a:bodyPr/>
                     <a:lstStyle/>
                     <a:p>
-                      <a:pPr algn="l" indent="0" marL="0">
+                      <a:pPr marL="0" indent="0" algn="l">
                         <a:buNone/>
                       </a:pPr>
                       <a:r>
@@ -6433,8 +6608,14 @@
                     <a:lnR w="0" cap="flat" cmpd="sng" algn="ctr">
                       <a:noFill/>
                     </a:lnR>
-                    <a:lnT w="0" cap="flat" cmpd="sng" algn="ctr">
-                      <a:noFill/>
+                    <a:lnT w="6350" cap="flat" cmpd="sng" algn="ctr">
+                      <a:solidFill>
+                        <a:srgbClr val="E3E3E3"/>
+                      </a:solidFill>
+                      <a:prstDash val="solid"/>
+                      <a:round/>
+                      <a:headEnd type="none" w="med" len="med"/>
+                      <a:tailEnd type="none" w="med" len="med"/>
                     </a:lnT>
                     <a:lnB w="6350" cap="flat" cmpd="sng" algn="ctr">
                       <a:solidFill>
@@ -6452,7 +6633,7 @@
                     <a:bodyPr/>
                     <a:lstStyle/>
                     <a:p>
-                      <a:pPr algn="r" indent="0" marL="0">
+                      <a:pPr marL="0" indent="0" algn="r">
                         <a:buNone/>
                       </a:pPr>
                       <a:r>
@@ -6480,8 +6661,14 @@
                     <a:lnR w="0" cap="flat" cmpd="sng" algn="ctr">
                       <a:noFill/>
                     </a:lnR>
-                    <a:lnT w="0" cap="flat" cmpd="sng" algn="ctr">
-                      <a:noFill/>
+                    <a:lnT w="6350" cap="flat" cmpd="sng" algn="ctr">
+                      <a:solidFill>
+                        <a:srgbClr val="E3E3E3"/>
+                      </a:solidFill>
+                      <a:prstDash val="solid"/>
+                      <a:round/>
+                      <a:headEnd type="none" w="med" len="med"/>
+                      <a:tailEnd type="none" w="med" len="med"/>
                     </a:lnT>
                     <a:lnB w="6350" cap="flat" cmpd="sng" algn="ctr">
                       <a:solidFill>
@@ -6499,7 +6686,7 @@
                     <a:bodyPr/>
                     <a:lstStyle/>
                     <a:p>
-                      <a:pPr algn="r" indent="0" marL="0">
+                      <a:pPr marL="0" indent="0" algn="r">
                         <a:buNone/>
                       </a:pPr>
                       <a:r>
@@ -6527,8 +6714,14 @@
                     <a:lnR w="0" cap="flat" cmpd="sng" algn="ctr">
                       <a:noFill/>
                     </a:lnR>
-                    <a:lnT w="0" cap="flat" cmpd="sng" algn="ctr">
-                      <a:noFill/>
+                    <a:lnT w="6350" cap="flat" cmpd="sng" algn="ctr">
+                      <a:solidFill>
+                        <a:srgbClr val="E3E3E3"/>
+                      </a:solidFill>
+                      <a:prstDash val="solid"/>
+                      <a:round/>
+                      <a:headEnd type="none" w="med" len="med"/>
+                      <a:tailEnd type="none" w="med" len="med"/>
                     </a:lnT>
                     <a:lnB w="6350" cap="flat" cmpd="sng" algn="ctr">
                       <a:solidFill>
@@ -6541,6 +6734,11 @@
                     </a:lnB>
                   </a:tcPr>
                 </a:tc>
+                <a:extLst>
+                  <a:ext uri="{0D108BD9-81ED-4DB2-BD59-A6C34878D82A}">
+                    <a16:rowId xmlns:a16="http://schemas.microsoft.com/office/drawing/2014/main" val="10005"/>
+                  </a:ext>
+                </a:extLst>
               </a:tr>
               <a:tr h="329184">
                 <a:tc>
@@ -6548,7 +6746,7 @@
                     <a:bodyPr/>
                     <a:lstStyle/>
                     <a:p>
-                      <a:pPr algn="l" indent="0" marL="0">
+                      <a:pPr marL="0" indent="0" algn="l">
                         <a:buNone/>
                       </a:pPr>
                       <a:r>
@@ -6576,8 +6774,14 @@
                     <a:lnR w="0" cap="flat" cmpd="sng" algn="ctr">
                       <a:noFill/>
                     </a:lnR>
-                    <a:lnT w="0" cap="flat" cmpd="sng" algn="ctr">
-                      <a:noFill/>
+                    <a:lnT w="6350" cap="flat" cmpd="sng" algn="ctr">
+                      <a:solidFill>
+                        <a:srgbClr val="E3E3E3"/>
+                      </a:solidFill>
+                      <a:prstDash val="solid"/>
+                      <a:round/>
+                      <a:headEnd type="none" w="med" len="med"/>
+                      <a:tailEnd type="none" w="med" len="med"/>
                     </a:lnT>
                     <a:lnB w="6350" cap="flat" cmpd="sng" algn="ctr">
                       <a:solidFill>
@@ -6595,7 +6799,7 @@
                     <a:bodyPr/>
                     <a:lstStyle/>
                     <a:p>
-                      <a:pPr algn="r" indent="0" marL="0">
+                      <a:pPr marL="0" indent="0" algn="r">
                         <a:buNone/>
                       </a:pPr>
                       <a:r>
@@ -6623,8 +6827,14 @@
                     <a:lnR w="0" cap="flat" cmpd="sng" algn="ctr">
                       <a:noFill/>
                     </a:lnR>
-                    <a:lnT w="0" cap="flat" cmpd="sng" algn="ctr">
-                      <a:noFill/>
+                    <a:lnT w="6350" cap="flat" cmpd="sng" algn="ctr">
+                      <a:solidFill>
+                        <a:srgbClr val="E3E3E3"/>
+                      </a:solidFill>
+                      <a:prstDash val="solid"/>
+                      <a:round/>
+                      <a:headEnd type="none" w="med" len="med"/>
+                      <a:tailEnd type="none" w="med" len="med"/>
                     </a:lnT>
                     <a:lnB w="6350" cap="flat" cmpd="sng" algn="ctr">
                       <a:solidFill>
@@ -6642,7 +6852,7 @@
                     <a:bodyPr/>
                     <a:lstStyle/>
                     <a:p>
-                      <a:pPr algn="r" indent="0" marL="0">
+                      <a:pPr marL="0" indent="0" algn="r">
                         <a:buNone/>
                       </a:pPr>
                       <a:r>
@@ -6670,8 +6880,14 @@
                     <a:lnR w="0" cap="flat" cmpd="sng" algn="ctr">
                       <a:noFill/>
                     </a:lnR>
-                    <a:lnT w="0" cap="flat" cmpd="sng" algn="ctr">
-                      <a:noFill/>
+                    <a:lnT w="6350" cap="flat" cmpd="sng" algn="ctr">
+                      <a:solidFill>
+                        <a:srgbClr val="E3E3E3"/>
+                      </a:solidFill>
+                      <a:prstDash val="solid"/>
+                      <a:round/>
+                      <a:headEnd type="none" w="med" len="med"/>
+                      <a:tailEnd type="none" w="med" len="med"/>
                     </a:lnT>
                     <a:lnB w="6350" cap="flat" cmpd="sng" algn="ctr">
                       <a:solidFill>
@@ -6684,6 +6900,11 @@
                     </a:lnB>
                   </a:tcPr>
                 </a:tc>
+                <a:extLst>
+                  <a:ext uri="{0D108BD9-81ED-4DB2-BD59-A6C34878D82A}">
+                    <a16:rowId xmlns:a16="http://schemas.microsoft.com/office/drawing/2014/main" val="10006"/>
+                  </a:ext>
+                </a:extLst>
               </a:tr>
               <a:tr h="329184">
                 <a:tc>
@@ -6691,7 +6912,7 @@
                     <a:bodyPr/>
                     <a:lstStyle/>
                     <a:p>
-                      <a:pPr algn="l" indent="0" marL="0">
+                      <a:pPr marL="0" indent="0" algn="l">
                         <a:buNone/>
                       </a:pPr>
                       <a:r>
@@ -6719,8 +6940,14 @@
                     <a:lnR w="0" cap="flat" cmpd="sng" algn="ctr">
                       <a:noFill/>
                     </a:lnR>
-                    <a:lnT w="0" cap="flat" cmpd="sng" algn="ctr">
-                      <a:noFill/>
+                    <a:lnT w="6350" cap="flat" cmpd="sng" algn="ctr">
+                      <a:solidFill>
+                        <a:srgbClr val="E3E3E3"/>
+                      </a:solidFill>
+                      <a:prstDash val="solid"/>
+                      <a:round/>
+                      <a:headEnd type="none" w="med" len="med"/>
+                      <a:tailEnd type="none" w="med" len="med"/>
                     </a:lnT>
                     <a:lnB w="15875" cap="flat" cmpd="sng" algn="ctr">
                       <a:solidFill>
@@ -6738,7 +6965,7 @@
                     <a:bodyPr/>
                     <a:lstStyle/>
                     <a:p>
-                      <a:pPr algn="r" indent="0" marL="0">
+                      <a:pPr marL="0" indent="0" algn="r">
                         <a:buNone/>
                       </a:pPr>
                       <a:r>
@@ -6766,8 +6993,14 @@
                     <a:lnR w="0" cap="flat" cmpd="sng" algn="ctr">
                       <a:noFill/>
                     </a:lnR>
-                    <a:lnT w="0" cap="flat" cmpd="sng" algn="ctr">
-                      <a:noFill/>
+                    <a:lnT w="6350" cap="flat" cmpd="sng" algn="ctr">
+                      <a:solidFill>
+                        <a:srgbClr val="E3E3E3"/>
+                      </a:solidFill>
+                      <a:prstDash val="solid"/>
+                      <a:round/>
+                      <a:headEnd type="none" w="med" len="med"/>
+                      <a:tailEnd type="none" w="med" len="med"/>
                     </a:lnT>
                     <a:lnB w="15875" cap="flat" cmpd="sng" algn="ctr">
                       <a:solidFill>
@@ -6785,7 +7018,7 @@
                     <a:bodyPr/>
                     <a:lstStyle/>
                     <a:p>
-                      <a:pPr algn="r" indent="0" marL="0">
+                      <a:pPr marL="0" indent="0" algn="r">
                         <a:buNone/>
                       </a:pPr>
                       <a:r>
@@ -6813,8 +7046,14 @@
                     <a:lnR w="0" cap="flat" cmpd="sng" algn="ctr">
                       <a:noFill/>
                     </a:lnR>
-                    <a:lnT w="0" cap="flat" cmpd="sng" algn="ctr">
-                      <a:noFill/>
+                    <a:lnT w="6350" cap="flat" cmpd="sng" algn="ctr">
+                      <a:solidFill>
+                        <a:srgbClr val="E3E3E3"/>
+                      </a:solidFill>
+                      <a:prstDash val="solid"/>
+                      <a:round/>
+                      <a:headEnd type="none" w="med" len="med"/>
+                      <a:tailEnd type="none" w="med" len="med"/>
                     </a:lnT>
                     <a:lnB w="15875" cap="flat" cmpd="sng" algn="ctr">
                       <a:solidFill>
@@ -6827,6 +7066,11 @@
                     </a:lnB>
                   </a:tcPr>
                 </a:tc>
+                <a:extLst>
+                  <a:ext uri="{0D108BD9-81ED-4DB2-BD59-A6C34878D82A}">
+                    <a16:rowId xmlns:a16="http://schemas.microsoft.com/office/drawing/2014/main" val="10007"/>
+                  </a:ext>
+                </a:extLst>
               </a:tr>
             </a:tbl>
           </a:graphicData>
@@ -6853,7 +7097,7 @@
           <a:bodyPr wrap="square" lIns="0" tIns="0" rIns="0" bIns="0" rtlCol="0" anchor="t"/>
           <a:lstStyle/>
           <a:p>
-            <a:pPr indent="0" marL="0">
+            <a:pPr marL="0" indent="0">
               <a:buNone/>
             </a:pPr>
             <a:r>
@@ -6884,16 +7128,34 @@
         </p:nvGraphicFramePr>
         <p:xfrm>
           <a:off x="5212080" y="1691640"/>
-          <a:ext cx="3383280" cy="914400"/>
+          <a:ext cx="3383280" cy="1316736"/>
         </p:xfrm>
         <a:graphic>
           <a:graphicData uri="http://schemas.openxmlformats.org/drawingml/2006/table">
             <a:tbl>
               <a:tblPr/>
               <a:tblGrid>
-                <a:gridCol w="1463040"/>
-                <a:gridCol w="960120"/>
-                <a:gridCol w="960120"/>
+                <a:gridCol w="1463040">
+                  <a:extLst>
+                    <a:ext uri="{9D8B030D-6E8A-4147-A177-3AD203B41FA5}">
+                      <a16:colId xmlns:a16="http://schemas.microsoft.com/office/drawing/2014/main" val="20000"/>
+                    </a:ext>
+                  </a:extLst>
+                </a:gridCol>
+                <a:gridCol w="960120">
+                  <a:extLst>
+                    <a:ext uri="{9D8B030D-6E8A-4147-A177-3AD203B41FA5}">
+                      <a16:colId xmlns:a16="http://schemas.microsoft.com/office/drawing/2014/main" val="20001"/>
+                    </a:ext>
+                  </a:extLst>
+                </a:gridCol>
+                <a:gridCol w="960120">
+                  <a:extLst>
+                    <a:ext uri="{9D8B030D-6E8A-4147-A177-3AD203B41FA5}">
+                      <a16:colId xmlns:a16="http://schemas.microsoft.com/office/drawing/2014/main" val="20002"/>
+                    </a:ext>
+                  </a:extLst>
+                </a:gridCol>
               </a:tblGrid>
               <a:tr h="329184">
                 <a:tc>
@@ -6901,7 +7163,7 @@
                     <a:bodyPr/>
                     <a:lstStyle/>
                     <a:p>
-                      <a:pPr algn="l" indent="0" marL="0">
+                      <a:pPr marL="0" indent="0" algn="l">
                         <a:buNone/>
                       </a:pPr>
                       <a:r>
@@ -6954,7 +7216,7 @@
                     <a:bodyPr/>
                     <a:lstStyle/>
                     <a:p>
-                      <a:pPr algn="r" indent="0" marL="0">
+                      <a:pPr marL="0" indent="0" algn="r">
                         <a:buNone/>
                       </a:pPr>
                       <a:r>
@@ -7007,7 +7269,7 @@
                     <a:bodyPr/>
                     <a:lstStyle/>
                     <a:p>
-                      <a:pPr algn="r" indent="0" marL="0">
+                      <a:pPr marL="0" indent="0" algn="r">
                         <a:buNone/>
                       </a:pPr>
                       <a:r>
@@ -7055,6 +7317,11 @@
                     </a:lnB>
                   </a:tcPr>
                 </a:tc>
+                <a:extLst>
+                  <a:ext uri="{0D108BD9-81ED-4DB2-BD59-A6C34878D82A}">
+                    <a16:rowId xmlns:a16="http://schemas.microsoft.com/office/drawing/2014/main" val="10000"/>
+                  </a:ext>
+                </a:extLst>
               </a:tr>
               <a:tr h="329184">
                 <a:tc>
@@ -7062,7 +7329,7 @@
                     <a:bodyPr/>
                     <a:lstStyle/>
                     <a:p>
-                      <a:pPr algn="l" indent="0" marL="0">
+                      <a:pPr marL="0" indent="0" algn="l">
                         <a:buNone/>
                       </a:pPr>
                       <a:r>
@@ -7090,8 +7357,14 @@
                     <a:lnR w="0" cap="flat" cmpd="sng" algn="ctr">
                       <a:noFill/>
                     </a:lnR>
-                    <a:lnT w="0" cap="flat" cmpd="sng" algn="ctr">
-                      <a:noFill/>
+                    <a:lnT w="9525" cap="flat" cmpd="sng" algn="ctr">
+                      <a:solidFill>
+                        <a:srgbClr val="222222"/>
+                      </a:solidFill>
+                      <a:prstDash val="solid"/>
+                      <a:round/>
+                      <a:headEnd type="none" w="med" len="med"/>
+                      <a:tailEnd type="none" w="med" len="med"/>
                     </a:lnT>
                     <a:lnB w="6350" cap="flat" cmpd="sng" algn="ctr">
                       <a:solidFill>
@@ -7109,7 +7382,7 @@
                     <a:bodyPr/>
                     <a:lstStyle/>
                     <a:p>
-                      <a:pPr algn="r" indent="0" marL="0">
+                      <a:pPr marL="0" indent="0" algn="r">
                         <a:buNone/>
                       </a:pPr>
                       <a:r>
@@ -7137,8 +7410,14 @@
                     <a:lnR w="0" cap="flat" cmpd="sng" algn="ctr">
                       <a:noFill/>
                     </a:lnR>
-                    <a:lnT w="0" cap="flat" cmpd="sng" algn="ctr">
-                      <a:noFill/>
+                    <a:lnT w="9525" cap="flat" cmpd="sng" algn="ctr">
+                      <a:solidFill>
+                        <a:srgbClr val="222222"/>
+                      </a:solidFill>
+                      <a:prstDash val="solid"/>
+                      <a:round/>
+                      <a:headEnd type="none" w="med" len="med"/>
+                      <a:tailEnd type="none" w="med" len="med"/>
                     </a:lnT>
                     <a:lnB w="6350" cap="flat" cmpd="sng" algn="ctr">
                       <a:solidFill>
@@ -7156,7 +7435,7 @@
                     <a:bodyPr/>
                     <a:lstStyle/>
                     <a:p>
-                      <a:pPr algn="r" indent="0" marL="0">
+                      <a:pPr marL="0" indent="0" algn="r">
                         <a:buNone/>
                       </a:pPr>
                       <a:r>
@@ -7184,8 +7463,14 @@
                     <a:lnR w="0" cap="flat" cmpd="sng" algn="ctr">
                       <a:noFill/>
                     </a:lnR>
-                    <a:lnT w="0" cap="flat" cmpd="sng" algn="ctr">
-                      <a:noFill/>
+                    <a:lnT w="9525" cap="flat" cmpd="sng" algn="ctr">
+                      <a:solidFill>
+                        <a:srgbClr val="222222"/>
+                      </a:solidFill>
+                      <a:prstDash val="solid"/>
+                      <a:round/>
+                      <a:headEnd type="none" w="med" len="med"/>
+                      <a:tailEnd type="none" w="med" len="med"/>
                     </a:lnT>
                     <a:lnB w="6350" cap="flat" cmpd="sng" algn="ctr">
                       <a:solidFill>
@@ -7198,6 +7483,11 @@
                     </a:lnB>
                   </a:tcPr>
                 </a:tc>
+                <a:extLst>
+                  <a:ext uri="{0D108BD9-81ED-4DB2-BD59-A6C34878D82A}">
+                    <a16:rowId xmlns:a16="http://schemas.microsoft.com/office/drawing/2014/main" val="10001"/>
+                  </a:ext>
+                </a:extLst>
               </a:tr>
               <a:tr h="329184">
                 <a:tc>
@@ -7205,7 +7495,7 @@
                     <a:bodyPr/>
                     <a:lstStyle/>
                     <a:p>
-                      <a:pPr algn="l" indent="0" marL="0">
+                      <a:pPr marL="0" indent="0" algn="l">
                         <a:buNone/>
                       </a:pPr>
                       <a:r>
@@ -7233,8 +7523,14 @@
                     <a:lnR w="0" cap="flat" cmpd="sng" algn="ctr">
                       <a:noFill/>
                     </a:lnR>
-                    <a:lnT w="0" cap="flat" cmpd="sng" algn="ctr">
-                      <a:noFill/>
+                    <a:lnT w="6350" cap="flat" cmpd="sng" algn="ctr">
+                      <a:solidFill>
+                        <a:srgbClr val="E3E3E3"/>
+                      </a:solidFill>
+                      <a:prstDash val="solid"/>
+                      <a:round/>
+                      <a:headEnd type="none" w="med" len="med"/>
+                      <a:tailEnd type="none" w="med" len="med"/>
                     </a:lnT>
                     <a:lnB w="6350" cap="flat" cmpd="sng" algn="ctr">
                       <a:solidFill>
@@ -7252,7 +7548,7 @@
                     <a:bodyPr/>
                     <a:lstStyle/>
                     <a:p>
-                      <a:pPr algn="r" indent="0" marL="0">
+                      <a:pPr marL="0" indent="0" algn="r">
                         <a:buNone/>
                       </a:pPr>
                       <a:r>
@@ -7280,8 +7576,14 @@
                     <a:lnR w="0" cap="flat" cmpd="sng" algn="ctr">
                       <a:noFill/>
                     </a:lnR>
-                    <a:lnT w="0" cap="flat" cmpd="sng" algn="ctr">
-                      <a:noFill/>
+                    <a:lnT w="6350" cap="flat" cmpd="sng" algn="ctr">
+                      <a:solidFill>
+                        <a:srgbClr val="E3E3E3"/>
+                      </a:solidFill>
+                      <a:prstDash val="solid"/>
+                      <a:round/>
+                      <a:headEnd type="none" w="med" len="med"/>
+                      <a:tailEnd type="none" w="med" len="med"/>
                     </a:lnT>
                     <a:lnB w="6350" cap="flat" cmpd="sng" algn="ctr">
                       <a:solidFill>
@@ -7299,7 +7601,7 @@
                     <a:bodyPr/>
                     <a:lstStyle/>
                     <a:p>
-                      <a:pPr algn="r" indent="0" marL="0">
+                      <a:pPr marL="0" indent="0" algn="r">
                         <a:buNone/>
                       </a:pPr>
                       <a:r>
@@ -7327,8 +7629,14 @@
                     <a:lnR w="0" cap="flat" cmpd="sng" algn="ctr">
                       <a:noFill/>
                     </a:lnR>
-                    <a:lnT w="0" cap="flat" cmpd="sng" algn="ctr">
-                      <a:noFill/>
+                    <a:lnT w="6350" cap="flat" cmpd="sng" algn="ctr">
+                      <a:solidFill>
+                        <a:srgbClr val="E3E3E3"/>
+                      </a:solidFill>
+                      <a:prstDash val="solid"/>
+                      <a:round/>
+                      <a:headEnd type="none" w="med" len="med"/>
+                      <a:tailEnd type="none" w="med" len="med"/>
                     </a:lnT>
                     <a:lnB w="6350" cap="flat" cmpd="sng" algn="ctr">
                       <a:solidFill>
@@ -7341,6 +7649,11 @@
                     </a:lnB>
                   </a:tcPr>
                 </a:tc>
+                <a:extLst>
+                  <a:ext uri="{0D108BD9-81ED-4DB2-BD59-A6C34878D82A}">
+                    <a16:rowId xmlns:a16="http://schemas.microsoft.com/office/drawing/2014/main" val="10002"/>
+                  </a:ext>
+                </a:extLst>
               </a:tr>
               <a:tr h="329184">
                 <a:tc>
@@ -7348,7 +7661,7 @@
                     <a:bodyPr/>
                     <a:lstStyle/>
                     <a:p>
-                      <a:pPr algn="l" indent="0" marL="0">
+                      <a:pPr marL="0" indent="0" algn="l">
                         <a:buNone/>
                       </a:pPr>
                       <a:r>
@@ -7376,8 +7689,14 @@
                     <a:lnR w="0" cap="flat" cmpd="sng" algn="ctr">
                       <a:noFill/>
                     </a:lnR>
-                    <a:lnT w="0" cap="flat" cmpd="sng" algn="ctr">
-                      <a:noFill/>
+                    <a:lnT w="6350" cap="flat" cmpd="sng" algn="ctr">
+                      <a:solidFill>
+                        <a:srgbClr val="E3E3E3"/>
+                      </a:solidFill>
+                      <a:prstDash val="solid"/>
+                      <a:round/>
+                      <a:headEnd type="none" w="med" len="med"/>
+                      <a:tailEnd type="none" w="med" len="med"/>
                     </a:lnT>
                     <a:lnB w="15875" cap="flat" cmpd="sng" algn="ctr">
                       <a:solidFill>
@@ -7395,7 +7714,7 @@
                     <a:bodyPr/>
                     <a:lstStyle/>
                     <a:p>
-                      <a:pPr algn="r" indent="0" marL="0">
+                      <a:pPr marL="0" indent="0" algn="r">
                         <a:buNone/>
                       </a:pPr>
                       <a:r>
@@ -7423,8 +7742,14 @@
                     <a:lnR w="0" cap="flat" cmpd="sng" algn="ctr">
                       <a:noFill/>
                     </a:lnR>
-                    <a:lnT w="0" cap="flat" cmpd="sng" algn="ctr">
-                      <a:noFill/>
+                    <a:lnT w="6350" cap="flat" cmpd="sng" algn="ctr">
+                      <a:solidFill>
+                        <a:srgbClr val="E3E3E3"/>
+                      </a:solidFill>
+                      <a:prstDash val="solid"/>
+                      <a:round/>
+                      <a:headEnd type="none" w="med" len="med"/>
+                      <a:tailEnd type="none" w="med" len="med"/>
                     </a:lnT>
                     <a:lnB w="15875" cap="flat" cmpd="sng" algn="ctr">
                       <a:solidFill>
@@ -7442,7 +7767,7 @@
                     <a:bodyPr/>
                     <a:lstStyle/>
                     <a:p>
-                      <a:pPr algn="r" indent="0" marL="0">
+                      <a:pPr marL="0" indent="0" algn="r">
                         <a:buNone/>
                       </a:pPr>
                       <a:r>
@@ -7470,8 +7795,14 @@
                     <a:lnR w="0" cap="flat" cmpd="sng" algn="ctr">
                       <a:noFill/>
                     </a:lnR>
-                    <a:lnT w="0" cap="flat" cmpd="sng" algn="ctr">
-                      <a:noFill/>
+                    <a:lnT w="6350" cap="flat" cmpd="sng" algn="ctr">
+                      <a:solidFill>
+                        <a:srgbClr val="E3E3E3"/>
+                      </a:solidFill>
+                      <a:prstDash val="solid"/>
+                      <a:round/>
+                      <a:headEnd type="none" w="med" len="med"/>
+                      <a:tailEnd type="none" w="med" len="med"/>
                     </a:lnT>
                     <a:lnB w="15875" cap="flat" cmpd="sng" algn="ctr">
                       <a:solidFill>
@@ -7484,6 +7815,11 @@
                     </a:lnB>
                   </a:tcPr>
                 </a:tc>
+                <a:extLst>
+                  <a:ext uri="{0D108BD9-81ED-4DB2-BD59-A6C34878D82A}">
+                    <a16:rowId xmlns:a16="http://schemas.microsoft.com/office/drawing/2014/main" val="10003"/>
+                  </a:ext>
+                </a:extLst>
               </a:tr>
             </a:tbl>
           </a:graphicData>
@@ -7510,7 +7846,7 @@
           <a:bodyPr wrap="square" lIns="0" tIns="0" rIns="0" bIns="0" rtlCol="0" anchor="t"/>
           <a:lstStyle/>
           <a:p>
-            <a:pPr indent="0" marL="0">
+            <a:pPr marL="0" indent="0">
               <a:buNone/>
             </a:pPr>
             <a:r>
@@ -7545,7 +7881,7 @@
           </a:prstGeom>
           <a:extLst>
             <a:ext uri="{C572A759-6A51-4108-AA02-DFA0A04FC94B}">
-              <ma14:wrappingTextBoxFlag xmlns:ma14="http://schemas.microsoft.com/office/mac/drawingml/2011/main" val="0"/>
+              <ma14:wrappingTextBoxFlag xmlns:ma14="http://schemas.microsoft.com/office/mac/drawingml/2011/main" xmlns="" val="0"/>
             </a:ext>
           </a:extLst>
         </p:spPr>
@@ -7563,7 +7899,7 @@
           <a:p>
             <a:pPr algn="r"/>
             <a:fld id="{F7021451-1387-4CA6-816F-3879F97B5CBC}" type="slidenum">
-              <a:rPr b="0" lang="en-US"/>
+              <a:rPr lang="en-US" b="0"/>
               <a:t>6</a:t>
             </a:fld>
             <a:endParaRPr lang="en-US"/>
@@ -7598,9 +7934,11 @@
       <p:sp>
         <p:nvSpPr>
           <p:cNvPr id="2" name="Text 0"/>
-          <p:cNvSpPr/>
+          <p:cNvSpPr>
+            <a:spLocks noGrp="1"/>
+          </p:cNvSpPr>
           <p:nvPr>
-            <p:ph idx="100" type="title" hasCustomPrompt="1"/>
+            <p:ph type="title" idx="100" hasCustomPrompt="1"/>
           </p:nvPr>
         </p:nvSpPr>
         <p:spPr>
@@ -7618,7 +7956,7 @@
           <a:bodyPr wrap="square" lIns="0" tIns="0" rIns="0" bIns="0" rtlCol="0" anchor="ctr"/>
           <a:lstStyle/>
           <a:p>
-            <a:pPr algn="l" indent="0" marL="0">
+            <a:pPr marL="0" indent="0" algn="l">
               <a:buNone/>
             </a:pPr>
             <a:r>
@@ -7654,7 +7992,7 @@
           <a:bodyPr wrap="square" lIns="0" tIns="0" rIns="0" bIns="0" rtlCol="0" anchor="t"/>
           <a:lstStyle/>
           <a:p>
-            <a:pPr indent="0" marL="0">
+            <a:pPr marL="0" indent="0">
               <a:buNone/>
             </a:pPr>
             <a:r>
@@ -7710,7 +8048,7 @@
           <a:bodyPr wrap="square" lIns="0" tIns="0" rIns="0" bIns="0" rtlCol="0" anchor="ctr"/>
           <a:lstStyle/>
           <a:p>
-            <a:pPr indent="0" marL="0">
+            <a:pPr marL="0" indent="0">
               <a:lnSpc>
                 <a:spcPct val="110000"/>
               </a:lnSpc>
@@ -7730,7 +8068,7 @@
             <a:endParaRPr lang="en-US" sz="1200" dirty="0"/>
           </a:p>
           <a:p>
-            <a:pPr indent="0" marL="0">
+            <a:pPr marL="0" indent="0">
               <a:lnSpc>
                 <a:spcPct val="110000"/>
               </a:lnSpc>
@@ -7761,7 +8099,7 @@
             <a:endParaRPr lang="en-US" sz="1200" dirty="0"/>
           </a:p>
           <a:p>
-            <a:pPr indent="0" marL="0">
+            <a:pPr marL="0" indent="0">
               <a:lnSpc>
                 <a:spcPct val="110000"/>
               </a:lnSpc>
@@ -7792,7 +8130,7 @@
             <a:endParaRPr lang="en-US" sz="1200" dirty="0"/>
           </a:p>
           <a:p>
-            <a:pPr indent="0" marL="0">
+            <a:pPr marL="0" indent="0">
               <a:lnSpc>
                 <a:spcPct val="110000"/>
               </a:lnSpc>
@@ -7812,7 +8150,7 @@
             <a:endParaRPr lang="en-US" sz="1200" dirty="0"/>
           </a:p>
           <a:p>
-            <a:pPr indent="0" marL="0">
+            <a:pPr marL="0" indent="0">
               <a:lnSpc>
                 <a:spcPct val="110000"/>
               </a:lnSpc>
@@ -7832,7 +8170,7 @@
             <a:endParaRPr lang="en-US" sz="1200" dirty="0"/>
           </a:p>
           <a:p>
-            <a:pPr indent="0" marL="0">
+            <a:pPr marL="0" indent="0">
               <a:lnSpc>
                 <a:spcPct val="110000"/>
               </a:lnSpc>
@@ -7852,7 +8190,7 @@
             <a:endParaRPr lang="en-US" sz="1200" dirty="0"/>
           </a:p>
           <a:p>
-            <a:pPr indent="0" marL="0">
+            <a:pPr marL="0" indent="0">
               <a:lnSpc>
                 <a:spcPct val="110000"/>
               </a:lnSpc>
@@ -7872,7 +8210,7 @@
             <a:endParaRPr lang="en-US" sz="1200" dirty="0"/>
           </a:p>
           <a:p>
-            <a:pPr indent="0" marL="0">
+            <a:pPr marL="0" indent="0">
               <a:lnSpc>
                 <a:spcPct val="110000"/>
               </a:lnSpc>
@@ -7903,7 +8241,7 @@
             <a:endParaRPr lang="en-US" sz="1200" dirty="0"/>
           </a:p>
           <a:p>
-            <a:pPr indent="0" marL="0">
+            <a:pPr marL="0" indent="0">
               <a:lnSpc>
                 <a:spcPct val="110000"/>
               </a:lnSpc>
@@ -7934,7 +8272,7 @@
             <a:endParaRPr lang="en-US" sz="1200" dirty="0"/>
           </a:p>
           <a:p>
-            <a:pPr indent="0" marL="0">
+            <a:pPr marL="0" indent="0">
               <a:lnSpc>
                 <a:spcPct val="110000"/>
               </a:lnSpc>
@@ -7987,7 +8325,7 @@
           <a:bodyPr wrap="square" lIns="0" tIns="0" rIns="0" bIns="0" rtlCol="0" anchor="t"/>
           <a:lstStyle/>
           <a:p>
-            <a:pPr indent="0" marL="0">
+            <a:pPr marL="0" indent="0">
               <a:buNone/>
             </a:pPr>
             <a:r>
@@ -8030,7 +8368,7 @@
           </a:prstGeom>
           <a:extLst>
             <a:ext uri="{C572A759-6A51-4108-AA02-DFA0A04FC94B}">
-              <ma14:wrappingTextBoxFlag xmlns:ma14="http://schemas.microsoft.com/office/mac/drawingml/2011/main" val="0"/>
+              <ma14:wrappingTextBoxFlag xmlns:ma14="http://schemas.microsoft.com/office/mac/drawingml/2011/main" xmlns="" val="0"/>
             </a:ext>
           </a:extLst>
         </p:spPr>
@@ -8048,7 +8386,7 @@
           <a:p>
             <a:pPr algn="r"/>
             <a:fld id="{F7021451-1387-4CA6-816F-3879F97B5CBC}" type="slidenum">
-              <a:rPr b="0" lang="en-US"/>
+              <a:rPr lang="en-US" b="0"/>
               <a:t>7</a:t>
             </a:fld>
             <a:endParaRPr lang="en-US"/>
@@ -8083,9 +8421,11 @@
       <p:sp>
         <p:nvSpPr>
           <p:cNvPr id="2" name="Text 0"/>
-          <p:cNvSpPr/>
+          <p:cNvSpPr>
+            <a:spLocks noGrp="1"/>
+          </p:cNvSpPr>
           <p:nvPr>
-            <p:ph idx="100" type="title" hasCustomPrompt="1"/>
+            <p:ph type="title" idx="100" hasCustomPrompt="1"/>
           </p:nvPr>
         </p:nvSpPr>
         <p:spPr>
@@ -8103,7 +8443,7 @@
           <a:bodyPr wrap="square" lIns="0" tIns="0" rIns="0" bIns="0" rtlCol="0" anchor="ctr"/>
           <a:lstStyle/>
           <a:p>
-            <a:pPr algn="l" indent="0" marL="0">
+            <a:pPr marL="0" indent="0" algn="l">
               <a:buNone/>
             </a:pPr>
             <a:r>
@@ -8139,7 +8479,7 @@
           <a:bodyPr wrap="square" lIns="0" tIns="0" rIns="0" bIns="0" rtlCol="0" anchor="t"/>
           <a:lstStyle/>
           <a:p>
-            <a:pPr indent="0" marL="0">
+            <a:pPr marL="0" indent="0">
               <a:buNone/>
             </a:pPr>
             <a:r>
@@ -8195,7 +8535,7 @@
           <a:bodyPr wrap="square" lIns="0" tIns="0" rIns="0" bIns="0" rtlCol="0" anchor="ctr"/>
           <a:lstStyle/>
           <a:p>
-            <a:pPr indent="0" marL="0">
+            <a:pPr marL="0" indent="0">
               <a:lnSpc>
                 <a:spcPct val="110000"/>
               </a:lnSpc>
@@ -8215,7 +8555,7 @@
             <a:endParaRPr lang="en-US" sz="1100" dirty="0"/>
           </a:p>
           <a:p>
-            <a:pPr indent="0" marL="0">
+            <a:pPr marL="0" indent="0">
               <a:lnSpc>
                 <a:spcPct val="110000"/>
               </a:lnSpc>
@@ -8235,7 +8575,7 @@
             <a:endParaRPr lang="en-US" sz="1100" dirty="0"/>
           </a:p>
           <a:p>
-            <a:pPr indent="0" marL="0">
+            <a:pPr marL="0" indent="0">
               <a:lnSpc>
                 <a:spcPct val="110000"/>
               </a:lnSpc>
@@ -8255,7 +8595,7 @@
             <a:endParaRPr lang="en-US" sz="1100" dirty="0"/>
           </a:p>
           <a:p>
-            <a:pPr indent="0" marL="0">
+            <a:pPr marL="0" indent="0">
               <a:lnSpc>
                 <a:spcPct val="110000"/>
               </a:lnSpc>
@@ -8275,7 +8615,7 @@
             <a:endParaRPr lang="en-US" sz="1100" dirty="0"/>
           </a:p>
           <a:p>
-            <a:pPr indent="0" marL="0">
+            <a:pPr marL="0" indent="0">
               <a:lnSpc>
                 <a:spcPct val="110000"/>
               </a:lnSpc>
@@ -8295,7 +8635,7 @@
             <a:endParaRPr lang="en-US" sz="1100" dirty="0"/>
           </a:p>
           <a:p>
-            <a:pPr indent="0" marL="0">
+            <a:pPr marL="0" indent="0">
               <a:lnSpc>
                 <a:spcPct val="110000"/>
               </a:lnSpc>
@@ -8315,7 +8655,7 @@
             <a:endParaRPr lang="en-US" sz="1100" dirty="0"/>
           </a:p>
           <a:p>
-            <a:pPr indent="0" marL="0">
+            <a:pPr marL="0" indent="0">
               <a:lnSpc>
                 <a:spcPct val="110000"/>
               </a:lnSpc>
@@ -8335,7 +8675,7 @@
             <a:endParaRPr lang="en-US" sz="1100" dirty="0"/>
           </a:p>
           <a:p>
-            <a:pPr indent="0" marL="0">
+            <a:pPr marL="0" indent="0">
               <a:lnSpc>
                 <a:spcPct val="110000"/>
               </a:lnSpc>
@@ -8355,7 +8695,7 @@
             <a:endParaRPr lang="en-US" sz="1100" dirty="0"/>
           </a:p>
           <a:p>
-            <a:pPr indent="0" marL="0">
+            <a:pPr marL="0" indent="0">
               <a:lnSpc>
                 <a:spcPct val="110000"/>
               </a:lnSpc>
@@ -8375,7 +8715,7 @@
             <a:endParaRPr lang="en-US" sz="1100" dirty="0"/>
           </a:p>
           <a:p>
-            <a:pPr indent="0" marL="0">
+            <a:pPr marL="0" indent="0">
               <a:lnSpc>
                 <a:spcPct val="110000"/>
               </a:lnSpc>
@@ -8395,7 +8735,7 @@
             <a:endParaRPr lang="en-US" sz="1100" dirty="0"/>
           </a:p>
           <a:p>
-            <a:pPr indent="0" marL="0">
+            <a:pPr marL="0" indent="0">
               <a:lnSpc>
                 <a:spcPct val="110000"/>
               </a:lnSpc>
@@ -8418,14 +8758,14 @@
       </p:sp>
       <p:pic>
         <p:nvPicPr>
-          <p:cNvPr id="6" name="spent figure" descr="/mnt/user-data/uploads/PPIA_HW1/figures/07_spent.png">    </p:cNvPr>
+          <p:cNvPr id="6" name="spent figure" descr="/mnt/user-data/uploads/PPIA_HW1/figures/07_spent.png"/>
           <p:cNvPicPr>
             <a:picLocks noChangeAspect="1"/>
           </p:cNvPicPr>
           <p:nvPr/>
         </p:nvPicPr>
         <p:blipFill>
-          <a:blip r:embed="rId1"/>
+          <a:blip r:embed="rId3"/>
           <a:stretch>
             <a:fillRect/>
           </a:stretch>
@@ -8461,7 +8801,7 @@
           <a:bodyPr wrap="square" lIns="0" tIns="0" rIns="0" bIns="0" rtlCol="0" anchor="t"/>
           <a:lstStyle/>
           <a:p>
-            <a:pPr indent="0" marL="0">
+            <a:pPr marL="0" indent="0">
               <a:buNone/>
             </a:pPr>
             <a:r>
@@ -8497,7 +8837,7 @@
           <a:bodyPr wrap="square" lIns="0" tIns="0" rIns="0" bIns="0" rtlCol="0" anchor="t"/>
           <a:lstStyle/>
           <a:p>
-            <a:pPr indent="0" marL="0">
+            <a:pPr marL="0" indent="0">
               <a:buNone/>
             </a:pPr>
             <a:r>
@@ -8540,7 +8880,7 @@
           </a:prstGeom>
           <a:extLst>
             <a:ext uri="{C572A759-6A51-4108-AA02-DFA0A04FC94B}">
-              <ma14:wrappingTextBoxFlag xmlns:ma14="http://schemas.microsoft.com/office/mac/drawingml/2011/main" val="0"/>
+              <ma14:wrappingTextBoxFlag xmlns:ma14="http://schemas.microsoft.com/office/mac/drawingml/2011/main" xmlns="" val="0"/>
             </a:ext>
           </a:extLst>
         </p:spPr>
@@ -8558,7 +8898,7 @@
           <a:p>
             <a:pPr algn="r"/>
             <a:fld id="{F7021451-1387-4CA6-816F-3879F97B5CBC}" type="slidenum">
-              <a:rPr b="0" lang="en-US"/>
+              <a:rPr lang="en-US" b="0"/>
               <a:t>8</a:t>
             </a:fld>
             <a:endParaRPr lang="en-US"/>
@@ -8593,9 +8933,11 @@
       <p:sp>
         <p:nvSpPr>
           <p:cNvPr id="2" name="Text 0"/>
-          <p:cNvSpPr/>
+          <p:cNvSpPr>
+            <a:spLocks noGrp="1"/>
+          </p:cNvSpPr>
           <p:nvPr>
-            <p:ph idx="100" type="title" hasCustomPrompt="1"/>
+            <p:ph type="title" idx="100" hasCustomPrompt="1"/>
           </p:nvPr>
         </p:nvSpPr>
         <p:spPr>
@@ -8613,7 +8955,7 @@
           <a:bodyPr wrap="square" lIns="0" tIns="0" rIns="0" bIns="0" rtlCol="0" anchor="ctr"/>
           <a:lstStyle/>
           <a:p>
-            <a:pPr algn="l" indent="0" marL="0">
+            <a:pPr marL="0" indent="0" algn="l">
               <a:buNone/>
             </a:pPr>
             <a:r>
@@ -8649,7 +8991,7 @@
           <a:bodyPr wrap="square" lIns="0" tIns="0" rIns="0" bIns="0" rtlCol="0" anchor="t"/>
           <a:lstStyle/>
           <a:p>
-            <a:pPr indent="0" marL="0">
+            <a:pPr marL="0" indent="0">
               <a:buNone/>
             </a:pPr>
             <a:r>
@@ -8705,7 +9047,7 @@
           <a:bodyPr wrap="square" lIns="0" tIns="0" rIns="0" bIns="0" rtlCol="0" anchor="ctr"/>
           <a:lstStyle/>
           <a:p>
-            <a:pPr indent="0" marL="0">
+            <a:pPr marL="0" indent="0">
               <a:lnSpc>
                 <a:spcPct val="110000"/>
               </a:lnSpc>
@@ -8725,7 +9067,7 @@
             <a:endParaRPr lang="en-US" sz="1200" dirty="0"/>
           </a:p>
           <a:p>
-            <a:pPr indent="0" marL="0">
+            <a:pPr marL="0" indent="0">
               <a:lnSpc>
                 <a:spcPct val="110000"/>
               </a:lnSpc>
@@ -8756,7 +9098,7 @@
             <a:endParaRPr lang="en-US" sz="1200" dirty="0"/>
           </a:p>
           <a:p>
-            <a:pPr indent="0" marL="0">
+            <a:pPr marL="0" indent="0">
               <a:lnSpc>
                 <a:spcPct val="110000"/>
               </a:lnSpc>
@@ -8776,7 +9118,7 @@
             <a:endParaRPr lang="en-US" sz="1200" dirty="0"/>
           </a:p>
           <a:p>
-            <a:pPr indent="0" marL="0">
+            <a:pPr marL="0" indent="0">
               <a:lnSpc>
                 <a:spcPct val="110000"/>
               </a:lnSpc>
@@ -8807,7 +9149,7 @@
             <a:endParaRPr lang="en-US" sz="1200" dirty="0"/>
           </a:p>
           <a:p>
-            <a:pPr indent="0" marL="0">
+            <a:pPr marL="0" indent="0">
               <a:lnSpc>
                 <a:spcPct val="110000"/>
               </a:lnSpc>
@@ -8827,7 +9169,7 @@
             <a:endParaRPr lang="en-US" sz="1200" dirty="0"/>
           </a:p>
           <a:p>
-            <a:pPr indent="0" marL="0">
+            <a:pPr marL="0" indent="0">
               <a:lnSpc>
                 <a:spcPct val="110000"/>
               </a:lnSpc>
@@ -8858,7 +9200,7 @@
             <a:endParaRPr lang="en-US" sz="1200" dirty="0"/>
           </a:p>
           <a:p>
-            <a:pPr indent="0" marL="0">
+            <a:pPr marL="0" indent="0">
               <a:lnSpc>
                 <a:spcPct val="110000"/>
               </a:lnSpc>
@@ -8999,7 +9341,7 @@
           </a:prstGeom>
           <a:extLst>
             <a:ext uri="{C572A759-6A51-4108-AA02-DFA0A04FC94B}">
-              <ma14:wrappingTextBoxFlag xmlns:ma14="http://schemas.microsoft.com/office/mac/drawingml/2011/main" val="0"/>
+              <ma14:wrappingTextBoxFlag xmlns:ma14="http://schemas.microsoft.com/office/mac/drawingml/2011/main" xmlns="" val="0"/>
             </a:ext>
           </a:extLst>
         </p:spPr>
@@ -9017,7 +9359,7 @@
           <a:p>
             <a:pPr algn="r"/>
             <a:fld id="{F7021451-1387-4CA6-816F-3879F97B5CBC}" type="slidenum">
-              <a:rPr b="0" lang="en-US"/>
+              <a:rPr lang="en-US" b="0"/>
               <a:t>9</a:t>
             </a:fld>
             <a:endParaRPr lang="en-US"/>
@@ -9325,4 +9667,299 @@
     </a:ext>
   </a:extLst>
 </a:theme>
+</file>
+
+<file path=ppt/theme/theme2.xml><?xml version="1.0" encoding="utf-8"?>
+<a:theme xmlns:a="http://schemas.openxmlformats.org/drawingml/2006/main" name="Office Theme">
+  <a:themeElements>
+    <a:clrScheme name="Office">
+      <a:dk1>
+        <a:sysClr val="windowText" lastClr="000000"/>
+      </a:dk1>
+      <a:lt1>
+        <a:sysClr val="window" lastClr="FFFFFF"/>
+      </a:lt1>
+      <a:dk2>
+        <a:srgbClr val="44546A"/>
+      </a:dk2>
+      <a:lt2>
+        <a:srgbClr val="E7E6E6"/>
+      </a:lt2>
+      <a:accent1>
+        <a:srgbClr val="4472C4"/>
+      </a:accent1>
+      <a:accent2>
+        <a:srgbClr val="ED7D31"/>
+      </a:accent2>
+      <a:accent3>
+        <a:srgbClr val="A5A5A5"/>
+      </a:accent3>
+      <a:accent4>
+        <a:srgbClr val="FFC000"/>
+      </a:accent4>
+      <a:accent5>
+        <a:srgbClr val="5B9BD5"/>
+      </a:accent5>
+      <a:accent6>
+        <a:srgbClr val="70AD47"/>
+      </a:accent6>
+      <a:hlink>
+        <a:srgbClr val="0563C1"/>
+      </a:hlink>
+      <a:folHlink>
+        <a:srgbClr val="954F72"/>
+      </a:folHlink>
+    </a:clrScheme>
+    <a:fontScheme name="Office">
+      <a:majorFont>
+        <a:latin typeface="Calibri Light" panose="020F0302020204030204"/>
+        <a:ea typeface=""/>
+        <a:cs typeface=""/>
+        <a:font script="Jpan" typeface="游ゴシック Light"/>
+        <a:font script="Hang" typeface="맑은 고딕"/>
+        <a:font script="Hans" typeface="等线 Light"/>
+        <a:font script="Hant" typeface="新細明體"/>
+        <a:font script="Arab" typeface="Times New Roman"/>
+        <a:font script="Hebr" typeface="Times New Roman"/>
+        <a:font script="Thai" typeface="Angsana New"/>
+        <a:font script="Ethi" typeface="Nyala"/>
+        <a:font script="Beng" typeface="Vrinda"/>
+        <a:font script="Gujr" typeface="Shruti"/>
+        <a:font script="Khmr" typeface="MoolBoran"/>
+        <a:font script="Knda" typeface="Tunga"/>
+        <a:font script="Guru" typeface="Raavi"/>
+        <a:font script="Cans" typeface="Euphemia"/>
+        <a:font script="Cher" typeface="Plantagenet Cherokee"/>
+        <a:font script="Yiii" typeface="Microsoft Yi Baiti"/>
+        <a:font script="Tibt" typeface="Microsoft Himalaya"/>
+        <a:font script="Thaa" typeface="MV Boli"/>
+        <a:font script="Deva" typeface="Mangal"/>
+        <a:font script="Telu" typeface="Gautami"/>
+        <a:font script="Taml" typeface="Latha"/>
+        <a:font script="Syrc" typeface="Estrangelo Edessa"/>
+        <a:font script="Orya" typeface="Kalinga"/>
+        <a:font script="Mlym" typeface="Kartika"/>
+        <a:font script="Laoo" typeface="DokChampa"/>
+        <a:font script="Sinh" typeface="Iskoola Pota"/>
+        <a:font script="Mong" typeface="Mongolian Baiti"/>
+        <a:font script="Viet" typeface="Times New Roman"/>
+        <a:font script="Uigh" typeface="Microsoft Uighur"/>
+        <a:font script="Geor" typeface="Sylfaen"/>
+        <a:font script="Armn" typeface="Arial"/>
+        <a:font script="Bugi" typeface="Leelawadee UI"/>
+        <a:font script="Bopo" typeface="Microsoft JhengHei"/>
+        <a:font script="Java" typeface="Javanese Text"/>
+        <a:font script="Lisu" typeface="Segoe UI"/>
+        <a:font script="Mymr" typeface="Myanmar Text"/>
+        <a:font script="Nkoo" typeface="Ebrima"/>
+        <a:font script="Olck" typeface="Nirmala UI"/>
+        <a:font script="Osma" typeface="Ebrima"/>
+        <a:font script="Phag" typeface="Phagspa"/>
+        <a:font script="Syrn" typeface="Estrangelo Edessa"/>
+        <a:font script="Syrj" typeface="Estrangelo Edessa"/>
+        <a:font script="Syre" typeface="Estrangelo Edessa"/>
+        <a:font script="Sora" typeface="Nirmala UI"/>
+        <a:font script="Tale" typeface="Microsoft Tai Le"/>
+        <a:font script="Talu" typeface="Microsoft New Tai Lue"/>
+        <a:font script="Tfng" typeface="Ebrima"/>
+      </a:majorFont>
+      <a:minorFont>
+        <a:latin typeface="Calibri" panose="020F0502020204030204"/>
+        <a:ea typeface=""/>
+        <a:cs typeface=""/>
+        <a:font script="Jpan" typeface="游ゴシック"/>
+        <a:font script="Hang" typeface="맑은 고딕"/>
+        <a:font script="Hans" typeface="等线"/>
+        <a:font script="Hant" typeface="新細明體"/>
+        <a:font script="Arab" typeface="Arial"/>
+        <a:font script="Hebr" typeface="Arial"/>
+        <a:font script="Thai" typeface="Cordia New"/>
+        <a:font script="Ethi" typeface="Nyala"/>
+        <a:font script="Beng" typeface="Vrinda"/>
+        <a:font script="Gujr" typeface="Shruti"/>
+        <a:font script="Khmr" typeface="DaunPenh"/>
+        <a:font script="Knda" typeface="Tunga"/>
+        <a:font script="Guru" typeface="Raavi"/>
+        <a:font script="Cans" typeface="Euphemia"/>
+        <a:font script="Cher" typeface="Plantagenet Cherokee"/>
+        <a:font script="Yiii" typeface="Microsoft Yi Baiti"/>
+        <a:font script="Tibt" typeface="Microsoft Himalaya"/>
+        <a:font script="Thaa" typeface="MV Boli"/>
+        <a:font script="Deva" typeface="Mangal"/>
+        <a:font script="Telu" typeface="Gautami"/>
+        <a:font script="Taml" typeface="Latha"/>
+        <a:font script="Syrc" typeface="Estrangelo Edessa"/>
+        <a:font script="Orya" typeface="Kalinga"/>
+        <a:font script="Mlym" typeface="Kartika"/>
+        <a:font script="Laoo" typeface="DokChampa"/>
+        <a:font script="Sinh" typeface="Iskoola Pota"/>
+        <a:font script="Mong" typeface="Mongolian Baiti"/>
+        <a:font script="Viet" typeface="Arial"/>
+        <a:font script="Uigh" typeface="Microsoft Uighur"/>
+        <a:font script="Geor" typeface="Sylfaen"/>
+        <a:font script="Armn" typeface="Arial"/>
+        <a:font script="Bugi" typeface="Leelawadee UI"/>
+        <a:font script="Bopo" typeface="Microsoft JhengHei"/>
+        <a:font script="Java" typeface="Javanese Text"/>
+        <a:font script="Lisu" typeface="Segoe UI"/>
+        <a:font script="Mymr" typeface="Myanmar Text"/>
+        <a:font script="Nkoo" typeface="Ebrima"/>
+        <a:font script="Olck" typeface="Nirmala UI"/>
+        <a:font script="Osma" typeface="Ebrima"/>
+        <a:font script="Phag" typeface="Phagspa"/>
+        <a:font script="Syrn" typeface="Estrangelo Edessa"/>
+        <a:font script="Syrj" typeface="Estrangelo Edessa"/>
+        <a:font script="Syre" typeface="Estrangelo Edessa"/>
+        <a:font script="Sora" typeface="Nirmala UI"/>
+        <a:font script="Tale" typeface="Microsoft Tai Le"/>
+        <a:font script="Talu" typeface="Microsoft New Tai Lue"/>
+        <a:font script="Tfng" typeface="Ebrima"/>
+      </a:minorFont>
+    </a:fontScheme>
+    <a:fmtScheme name="Office">
+      <a:fillStyleLst>
+        <a:solidFill>
+          <a:schemeClr val="phClr"/>
+        </a:solidFill>
+        <a:gradFill rotWithShape="1">
+          <a:gsLst>
+            <a:gs pos="0">
+              <a:schemeClr val="phClr">
+                <a:lumMod val="110000"/>
+                <a:satMod val="105000"/>
+                <a:tint val="67000"/>
+              </a:schemeClr>
+            </a:gs>
+            <a:gs pos="50000">
+              <a:schemeClr val="phClr">
+                <a:lumMod val="105000"/>
+                <a:satMod val="103000"/>
+                <a:tint val="73000"/>
+              </a:schemeClr>
+            </a:gs>
+            <a:gs pos="100000">
+              <a:schemeClr val="phClr">
+                <a:lumMod val="105000"/>
+                <a:satMod val="109000"/>
+                <a:tint val="81000"/>
+              </a:schemeClr>
+            </a:gs>
+          </a:gsLst>
+          <a:lin ang="5400000" scaled="0"/>
+        </a:gradFill>
+        <a:gradFill rotWithShape="1">
+          <a:gsLst>
+            <a:gs pos="0">
+              <a:schemeClr val="phClr">
+                <a:satMod val="103000"/>
+                <a:lumMod val="102000"/>
+                <a:tint val="94000"/>
+              </a:schemeClr>
+            </a:gs>
+            <a:gs pos="50000">
+              <a:schemeClr val="phClr">
+                <a:satMod val="110000"/>
+                <a:lumMod val="100000"/>
+                <a:shade val="100000"/>
+              </a:schemeClr>
+            </a:gs>
+            <a:gs pos="100000">
+              <a:schemeClr val="phClr">
+                <a:lumMod val="99000"/>
+                <a:satMod val="120000"/>
+                <a:shade val="78000"/>
+              </a:schemeClr>
+            </a:gs>
+          </a:gsLst>
+          <a:lin ang="5400000" scaled="0"/>
+        </a:gradFill>
+      </a:fillStyleLst>
+      <a:lnStyleLst>
+        <a:ln w="6350" cap="flat" cmpd="sng" algn="ctr">
+          <a:solidFill>
+            <a:schemeClr val="phClr"/>
+          </a:solidFill>
+          <a:prstDash val="solid"/>
+          <a:miter lim="800000"/>
+        </a:ln>
+        <a:ln w="12700" cap="flat" cmpd="sng" algn="ctr">
+          <a:solidFill>
+            <a:schemeClr val="phClr"/>
+          </a:solidFill>
+          <a:prstDash val="solid"/>
+          <a:miter lim="800000"/>
+        </a:ln>
+        <a:ln w="19050" cap="flat" cmpd="sng" algn="ctr">
+          <a:solidFill>
+            <a:schemeClr val="phClr"/>
+          </a:solidFill>
+          <a:prstDash val="solid"/>
+          <a:miter lim="800000"/>
+        </a:ln>
+      </a:lnStyleLst>
+      <a:effectStyleLst>
+        <a:effectStyle>
+          <a:effectLst/>
+        </a:effectStyle>
+        <a:effectStyle>
+          <a:effectLst/>
+        </a:effectStyle>
+        <a:effectStyle>
+          <a:effectLst>
+            <a:outerShdw blurRad="57150" dist="19050" dir="5400000" algn="ctr" rotWithShape="0">
+              <a:srgbClr val="000000">
+                <a:alpha val="63000"/>
+              </a:srgbClr>
+            </a:outerShdw>
+          </a:effectLst>
+        </a:effectStyle>
+      </a:effectStyleLst>
+      <a:bgFillStyleLst>
+        <a:solidFill>
+          <a:schemeClr val="phClr"/>
+        </a:solidFill>
+        <a:solidFill>
+          <a:schemeClr val="phClr">
+            <a:tint val="95000"/>
+            <a:satMod val="170000"/>
+          </a:schemeClr>
+        </a:solidFill>
+        <a:gradFill rotWithShape="1">
+          <a:gsLst>
+            <a:gs pos="0">
+              <a:schemeClr val="phClr">
+                <a:tint val="93000"/>
+                <a:satMod val="150000"/>
+                <a:shade val="98000"/>
+                <a:lumMod val="102000"/>
+              </a:schemeClr>
+            </a:gs>
+            <a:gs pos="50000">
+              <a:schemeClr val="phClr">
+                <a:tint val="98000"/>
+                <a:satMod val="130000"/>
+                <a:shade val="90000"/>
+                <a:lumMod val="103000"/>
+              </a:schemeClr>
+            </a:gs>
+            <a:gs pos="100000">
+              <a:schemeClr val="phClr">
+                <a:shade val="63000"/>
+                <a:satMod val="120000"/>
+              </a:schemeClr>
+            </a:gs>
+          </a:gsLst>
+          <a:lin ang="5400000" scaled="0"/>
+        </a:gradFill>
+      </a:bgFillStyleLst>
+    </a:fmtScheme>
+  </a:themeElements>
+  <a:objectDefaults/>
+  <a:extraClrSchemeLst/>
+  <a:extLst>
+    <a:ext uri="{05A4C25C-085E-4340-85A3-A5531E510DB2}">
+      <thm15:themeFamily xmlns:thm15="http://schemas.microsoft.com/office/thememl/2012/main" name="Office Theme" id="{62F939B6-93AF-4DB8-9C6B-D6C7DFDC589F}" vid="{4A3C46E8-61CC-4603-A589-7422A47A8E4A}"/>
+    </a:ext>
+  </a:extLst>
+</a:theme>
 </file>
</xml_diff>